<commit_message>
docs(gtu): update HOD name to Cirag D. Patel
</commit_message>
<xml_diff>
--- a/docs/DineFlow_AI_GTU_Minor_Project_Presentation.pptx
+++ b/docs/DineFlow_AI_GTU_Minor_Project_Presentation.pptx
@@ -3371,7 +3371,7 @@
               </a:defRPr>
             </a:pPr>
             <a:r>
-              <a:t>Head of Department: Dr. Chirag D. Patel</a:t>
+              <a:t>Head of Department: Cirag D. Patel</a:t>
             </a:r>
           </a:p>
           <a:p>
@@ -3383,7 +3383,7 @@
               </a:defRPr>
             </a:pPr>
             <a:r>
-              <a:t>  (I/C HOD, Computer Engg. Dept.)</a:t>
+              <a:t>  (HOD, Computer Engg. Dept.)</a:t>
             </a:r>
           </a:p>
           <a:p>
@@ -7436,7 +7436,7 @@
               </a:defRPr>
             </a:pPr>
             <a:r>
-              <a:t>Head of Dept: Dr. Chirag D. Patel</a:t>
+              <a:t>Head of Dept: Cirag D. Patel</a:t>
             </a:r>
           </a:p>
           <a:p>

</xml_diff>

<commit_message>
docs(gtu): finalize official faculty details with Dr. Chirag D. Patel, Prof. Yagnesh Patel, and Principal H. C. Parmar
</commit_message>
<xml_diff>
--- a/docs/DineFlow_AI_GTU_Minor_Project_Presentation.pptx
+++ b/docs/DineFlow_AI_GTU_Minor_Project_Presentation.pptx
@@ -3371,7 +3371,7 @@
               </a:defRPr>
             </a:pPr>
             <a:r>
-              <a:t>Head of Department: Cirag D. Patel</a:t>
+              <a:t>Head of Department: Dr. Chirag D. Patel</a:t>
             </a:r>
           </a:p>
           <a:p>
@@ -3383,7 +3383,7 @@
               </a:defRPr>
             </a:pPr>
             <a:r>
-              <a:t>  (HOD, Computer Engg. Dept.)</a:t>
+              <a:t>  (Head, Computer Engg. Dept.)</a:t>
             </a:r>
           </a:p>
           <a:p>
@@ -7436,7 +7436,7 @@
               </a:defRPr>
             </a:pPr>
             <a:r>
-              <a:t>Head of Dept: Cirag D. Patel</a:t>
+              <a:t>Head of Dept: Dr. Chirag D. Patel</a:t>
             </a:r>
           </a:p>
           <a:p>

</xml_diff>

<commit_message>
docs(gtu): set SSIP status as Proposed & Under Preparation
</commit_message>
<xml_diff>
--- a/docs/DineFlow_AI_GTU_Minor_Project_Presentation.pptx
+++ b/docs/DineFlow_AI_GTU_Minor_Project_Presentation.pptx
@@ -6974,15 +6974,15 @@
               </a:defRPr>
             </a:pPr>
             <a:r>
-              <a:t>• Eligible for Student Startup &amp; Innovation Policy (SSIP 2.0) PoC/Prototype Grant of up to ₹ 2.50 Lakhs.</a:t>
+              <a:t>• Status: Proposed &amp; Eligible (PoC/Prototype Grant up to ₹ 2.50 Lakhs).</a:t>
             </a:r>
             <a:br/>
             <a:r>
-              <a:t>• Application Focus: Supporting Tier-2/Tier-3 town restaurants with regional language Gujarati Soundbox &amp; automated recipe costing.</a:t>
+              <a:t>• Proposal Stage: In pipeline for submission to K. D. Polytechnic SSIP Innovation Council.</a:t>
             </a:r>
             <a:br/>
             <a:r>
-              <a:t>• Mentorship: Guided by K. D. Polytechnic SSIP Innovation Council.</a:t>
+              <a:t>• Target Use: Deploying thermal printers &amp; pilot trials in local Patan restaurants.</a:t>
             </a:r>
           </a:p>
         </p:txBody>

</xml_diff>

<commit_message>
docs(gtu): remove SSIP references and replace with 100% bootstrapped commercial SaaS business model
</commit_message>
<xml_diff>
--- a/docs/DineFlow_AI_GTU_Minor_Project_Presentation.pptx
+++ b/docs/DineFlow_AI_GTU_Minor_Project_Presentation.pptx
@@ -3793,7 +3793,7 @@
                         </a:defRPr>
                       </a:pPr>
                       <a:r>
-                        <a:t>₹ 0 (Free Tier / SSIP)</a:t>
+                        <a:t>₹ 0 (AWS Free Tier / Self-Hosted)</a:t>
                       </a:r>
                     </a:p>
                   </a:txBody>
@@ -6770,7 +6770,7 @@
               </a:defRPr>
             </a:pPr>
             <a:r>
-              <a:t>Startup, SSIP Grant &amp; Patent Potential</a:t>
+              <a:t>Commercial Startup &amp; Business Model</a:t>
             </a:r>
           </a:p>
         </p:txBody>
@@ -6892,11 +6892,11 @@
             </a:r>
             <a:br/>
             <a:r>
-              <a:t>• Revenue Model: Affordable B2B SaaS subscription (₹499 - ₹1,499/mo) + source code licensing.</a:t>
+              <a:t>• Live Traction: Production platform operational at dineflowai.duckdns.org.</a:t>
             </a:r>
             <a:br/>
             <a:r>
-              <a:t>• Live Traction: Functional prototype live at dineflowai.duckdns.org.</a:t>
+              <a:t>• High Scalability: Multi-tenant database supports thousands of restaurants simultaneously.</a:t>
             </a:r>
           </a:p>
         </p:txBody>
@@ -6950,7 +6950,7 @@
               </a:defRPr>
             </a:pPr>
             <a:r>
-              <a:t>2. SSIP 2.0 Grant Scheme</a:t>
+              <a:t>2. Revenue &amp; Pricing Model</a:t>
             </a:r>
           </a:p>
           <a:p>
@@ -6962,7 +6962,7 @@
               </a:defRPr>
             </a:pPr>
             <a:r>
-              <a:t>Government of Gujarat</a:t>
+              <a:t>Self-Sustaining SaaS</a:t>
             </a:r>
           </a:p>
           <a:p>
@@ -6974,15 +6974,19 @@
               </a:defRPr>
             </a:pPr>
             <a:r>
-              <a:t>• Status: Proposed &amp; Eligible (PoC/Prototype Grant up to ₹ 2.50 Lakhs).</a:t>
+              <a:t>• Starter Plan: ₹ 499 / month (Single counter QSR &amp; cafes).</a:t>
             </a:r>
             <a:br/>
             <a:r>
-              <a:t>• Proposal Stage: In pipeline for submission to K. D. Polytechnic SSIP Innovation Council.</a:t>
+              <a:t>• Pro Restaurant: ₹ 1,499 / month (Full KDS, inventory &amp; multi-table).</a:t>
             </a:r>
             <a:br/>
             <a:r>
-              <a:t>• Target Use: Deploying thermal printers &amp; pilot trials in local Patan restaurants.</a:t>
+              <a:t>• Source Code Buyout: One-time commercial developer license.</a:t>
+            </a:r>
+            <a:br/>
+            <a:r>
+              <a:t>• 100% Bootstrapped: Zero debt or external grant dependency; profitable from Day 1.</a:t>
             </a:r>
           </a:p>
         </p:txBody>
@@ -7761,7 +7765,7 @@
               </a:defRPr>
             </a:pPr>
             <a:r>
-              <a:t>[7]  Conclusion, Future Scope &amp; SSIP 2.0 Entrepreneurship</a:t>
+              <a:t>[7]  Conclusion, Future Scope &amp; Commercial Startup Potential</a:t>
             </a:r>
           </a:p>
           <a:p>
@@ -7773,7 +7777,7 @@
               </a:defRPr>
             </a:pPr>
             <a:r>
-              <a:t>      Commercial validation at dineflowai.duckdns.org &amp; SSIP startup potential</a:t>
+              <a:t>      Commercial validation at dineflowai.duckdns.org &amp; B2B SaaS model</a:t>
             </a:r>
           </a:p>
         </p:txBody>

</xml_diff>

<commit_message>
docs(gtu): add Section 5.3 with Figure 4 assembled prototype photos and Appendix A code listings/datasheets
</commit_message>
<xml_diff>
--- a/docs/DineFlow_AI_GTU_Minor_Project_Presentation.pptx
+++ b/docs/DineFlow_AI_GTU_Minor_Project_Presentation.pptx
@@ -5669,7 +5669,7 @@
               </a:defRPr>
             </a:pPr>
             <a:r>
-              <a:t>Prototype / Model Development</a:t>
+              <a:t>Prototype / Model Development (Figure 4)</a:t>
             </a:r>
           </a:p>
         </p:txBody>
@@ -5774,17 +5774,97 @@
         </p:blipFill>
         <p:spPr>
           <a:xfrm>
-            <a:off x="914400" y="1371600"/>
-            <a:ext cx="4937760" cy="3291840"/>
+            <a:off x="731520" y="1371600"/>
+            <a:ext cx="3383280" cy="2286000"/>
           </a:xfrm>
           <a:prstGeom prst="rect">
             <a:avLst/>
           </a:prstGeom>
         </p:spPr>
       </p:pic>
+      <p:sp>
+        <p:nvSpPr>
+          <p:cNvPr id="9" name="Rounded Rectangle 8"/>
+          <p:cNvSpPr/>
+          <p:nvPr/>
+        </p:nvSpPr>
+        <p:spPr>
+          <a:xfrm>
+            <a:off x="731520" y="3749039"/>
+            <a:ext cx="3383280" cy="1828800"/>
+          </a:xfrm>
+          <a:prstGeom prst="roundRect">
+            <a:avLst/>
+          </a:prstGeom>
+          <a:solidFill>
+            <a:srgbClr val="F8FAFC"/>
+          </a:solidFill>
+          <a:ln>
+            <a:solidFill>
+              <a:srgbClr val="E2E8F0"/>
+            </a:solidFill>
+          </a:ln>
+        </p:spPr>
+        <p:style>
+          <a:lnRef idx="1">
+            <a:schemeClr val="accent1"/>
+          </a:lnRef>
+          <a:fillRef idx="3">
+            <a:schemeClr val="accent1"/>
+          </a:fillRef>
+          <a:effectRef idx="2">
+            <a:schemeClr val="accent1"/>
+          </a:effectRef>
+          <a:fontRef idx="minor">
+            <a:schemeClr val="lt1"/>
+          </a:fontRef>
+        </p:style>
+        <p:txBody>
+          <a:bodyPr rtlCol="0" anchor="ctr" wrap="square"/>
+          <a:lstStyle/>
+          <a:p>
+            <a:pPr algn="ctr">
+              <a:defRPr b="1" sz="1200">
+                <a:solidFill>
+                  <a:srgbClr val="4F46E5"/>
+                </a:solidFill>
+                <a:latin typeface="Calibri"/>
+              </a:defRPr>
+            </a:pPr>
+            <a:r>
+              <a:t>Figure 4(a): Web POS Terminal</a:t>
+            </a:r>
+          </a:p>
+          <a:p>
+            <a:pPr>
+              <a:defRPr sz="1050">
+                <a:solidFill>
+                  <a:srgbClr val="1E293B"/>
+                </a:solidFill>
+                <a:latin typeface="Calibri"/>
+              </a:defRPr>
+            </a:pPr>
+            <a:r>
+              <a:t>• Sub-3s checkout billing engine</a:t>
+            </a:r>
+            <a:br/>
+            <a:r>
+              <a:t>• Keyboard navigation (F1-F9)</a:t>
+            </a:r>
+            <a:br/>
+            <a:r>
+              <a:t>• Dynamic cart &amp; UPI QR billing</a:t>
+            </a:r>
+            <a:br/>
+            <a:r>
+              <a:t>• Zero local installation needed</a:t>
+            </a:r>
+          </a:p>
+        </p:txBody>
+      </p:sp>
       <p:pic>
         <p:nvPicPr>
-          <p:cNvPr id="9" name="Picture 8" descr="about_img_1.png"/>
+          <p:cNvPr id="10" name="Picture 9" descr="pos_thermal_printer.jpg"/>
           <p:cNvPicPr>
             <a:picLocks noChangeAspect="1"/>
           </p:cNvPicPr>
@@ -5798,8 +5878,8 @@
         </p:blipFill>
         <p:spPr>
           <a:xfrm>
-            <a:off x="6309360" y="1371600"/>
-            <a:ext cx="4937760" cy="3291840"/>
+            <a:off x="4389120" y="1371600"/>
+            <a:ext cx="3383280" cy="2286000"/>
           </a:xfrm>
           <a:prstGeom prst="rect">
             <a:avLst/>
@@ -5808,28 +5888,164 @@
       </p:pic>
       <p:sp>
         <p:nvSpPr>
-          <p:cNvPr id="10" name="TextBox 9"/>
-          <p:cNvSpPr txBox="1"/>
-          <p:nvPr/>
-        </p:nvSpPr>
-        <p:spPr>
-          <a:xfrm>
-            <a:off x="914400" y="4846320"/>
-            <a:ext cx="10362895" cy="1645920"/>
+          <p:cNvPr id="11" name="Rounded Rectangle 10"/>
+          <p:cNvSpPr/>
+          <p:nvPr/>
+        </p:nvSpPr>
+        <p:spPr>
+          <a:xfrm>
+            <a:off x="4389120" y="3749039"/>
+            <a:ext cx="3383280" cy="1828800"/>
+          </a:xfrm>
+          <a:prstGeom prst="roundRect">
+            <a:avLst/>
+          </a:prstGeom>
+          <a:solidFill>
+            <a:srgbClr val="F8FAFC"/>
+          </a:solidFill>
+          <a:ln>
+            <a:solidFill>
+              <a:srgbClr val="E2E8F0"/>
+            </a:solidFill>
+          </a:ln>
+        </p:spPr>
+        <p:style>
+          <a:lnRef idx="1">
+            <a:schemeClr val="accent1"/>
+          </a:lnRef>
+          <a:fillRef idx="3">
+            <a:schemeClr val="accent1"/>
+          </a:fillRef>
+          <a:effectRef idx="2">
+            <a:schemeClr val="accent1"/>
+          </a:effectRef>
+          <a:fontRef idx="minor">
+            <a:schemeClr val="lt1"/>
+          </a:fontRef>
+        </p:style>
+        <p:txBody>
+          <a:bodyPr rtlCol="0" anchor="ctr" wrap="square"/>
+          <a:lstStyle/>
+          <a:p>
+            <a:pPr algn="ctr">
+              <a:defRPr b="1" sz="1200">
+                <a:solidFill>
+                  <a:srgbClr val="4F46E5"/>
+                </a:solidFill>
+                <a:latin typeface="Calibri"/>
+              </a:defRPr>
+            </a:pPr>
+            <a:r>
+              <a:t>Figure 4(b): Assembled Hardware Setup</a:t>
+            </a:r>
+          </a:p>
+          <a:p>
+            <a:pPr>
+              <a:defRPr sz="1050">
+                <a:solidFill>
+                  <a:srgbClr val="1E293B"/>
+                </a:solidFill>
+                <a:latin typeface="Calibri"/>
+              </a:defRPr>
+            </a:pPr>
+            <a:r>
+              <a:t>• 58mm/80mm ESC/POS printer</a:t>
+            </a:r>
+            <a:br/>
+            <a:r>
+              <a:t>• Silent raw byte-stream driver</a:t>
+            </a:r>
+            <a:br/>
+            <a:r>
+              <a:t>• Automatic guillotine cutter</a:t>
+            </a:r>
+            <a:br/>
+            <a:r>
+              <a:t>• Hardware cost under ₹2,800</a:t>
+            </a:r>
+          </a:p>
+        </p:txBody>
+      </p:sp>
+      <p:pic>
+        <p:nvPicPr>
+          <p:cNvPr id="12" name="Picture 11" descr="about_img_1.png"/>
+          <p:cNvPicPr>
+            <a:picLocks noChangeAspect="1"/>
+          </p:cNvPicPr>
+          <p:nvPr/>
+        </p:nvPicPr>
+        <p:blipFill>
+          <a:blip r:embed="rId6"/>
+          <a:stretch>
+            <a:fillRect/>
+          </a:stretch>
+        </p:blipFill>
+        <p:spPr>
+          <a:xfrm>
+            <a:off x="8046720" y="1371600"/>
+            <a:ext cx="3383280" cy="2286000"/>
           </a:xfrm>
           <a:prstGeom prst="rect">
             <a:avLst/>
           </a:prstGeom>
-          <a:noFill/>
-        </p:spPr>
-        <p:txBody>
-          <a:bodyPr wrap="square">
-            <a:spAutoFit/>
-          </a:bodyPr>
-          <a:lstStyle/>
+        </p:spPr>
+      </p:pic>
+      <p:sp>
+        <p:nvSpPr>
+          <p:cNvPr id="13" name="Rounded Rectangle 12"/>
+          <p:cNvSpPr/>
+          <p:nvPr/>
+        </p:nvSpPr>
+        <p:spPr>
+          <a:xfrm>
+            <a:off x="8046720" y="3749039"/>
+            <a:ext cx="3383280" cy="1828800"/>
+          </a:xfrm>
+          <a:prstGeom prst="roundRect">
+            <a:avLst/>
+          </a:prstGeom>
+          <a:solidFill>
+            <a:srgbClr val="F8FAFC"/>
+          </a:solidFill>
+          <a:ln>
+            <a:solidFill>
+              <a:srgbClr val="E2E8F0"/>
+            </a:solidFill>
+          </a:ln>
+        </p:spPr>
+        <p:style>
+          <a:lnRef idx="1">
+            <a:schemeClr val="accent1"/>
+          </a:lnRef>
+          <a:fillRef idx="3">
+            <a:schemeClr val="accent1"/>
+          </a:fillRef>
+          <a:effectRef idx="2">
+            <a:schemeClr val="accent1"/>
+          </a:effectRef>
+          <a:fontRef idx="minor">
+            <a:schemeClr val="lt1"/>
+          </a:fontRef>
+        </p:style>
+        <p:txBody>
+          <a:bodyPr rtlCol="0" anchor="ctr" wrap="square"/>
+          <a:lstStyle/>
+          <a:p>
+            <a:pPr algn="ctr">
+              <a:defRPr b="1" sz="1200">
+                <a:solidFill>
+                  <a:srgbClr val="4F46E5"/>
+                </a:solidFill>
+                <a:latin typeface="Calibri"/>
+              </a:defRPr>
+            </a:pPr>
+            <a:r>
+              <a:t>Figure 4(c): Cloud Management ERP</a:t>
+            </a:r>
+          </a:p>
           <a:p>
             <a:pPr>
-              <a:defRPr sz="1150">
+              <a:defRPr sz="1050">
                 <a:solidFill>
                   <a:srgbClr val="1E293B"/>
                 </a:solidFill>
@@ -5837,33 +6053,74 @@
               </a:defRPr>
             </a:pPr>
             <a:r>
-              <a:t>Left: Authentic DineFlow AI Real-Time Web POS Terminal with active cart, discounts, and UPI QR code.</a:t>
-            </a:r>
-          </a:p>
-          <a:p>
-            <a:pPr>
-              <a:defRPr sz="1150">
-                <a:solidFill>
-                  <a:srgbClr val="1E293B"/>
-                </a:solidFill>
-                <a:latin typeface="Calibri"/>
-              </a:defRPr>
-            </a:pPr>
-            <a:r>
-              <a:t>Right: Authentic DineFlow AI Operations &amp; Revenue Analytics Dashboard with AI Menu Engineering Matrix.</a:t>
-            </a:r>
-          </a:p>
-          <a:p>
-            <a:pPr>
-              <a:defRPr b="1" sz="1200">
-                <a:solidFill>
-                  <a:srgbClr val="4F46E5"/>
-                </a:solidFill>
-                <a:latin typeface="Calibri"/>
-              </a:defRPr>
-            </a:pPr>
-            <a:r>
-              <a:t>Live Cloud Server URL: https://dineflowai.duckdns.org (Hosted on AWS EC2 Ubuntu Server)</a:t>
+              <a:t>• BCG AI menu engineering matrix</a:t>
+            </a:r>
+            <a:br/>
+            <a:r>
+              <a:t>• Raw recipe auto-depletion engine</a:t>
+            </a:r>
+            <a:br/>
+            <a:r>
+              <a:t>• Sub-180ms live kitchen KDS</a:t>
+            </a:r>
+            <a:br/>
+            <a:r>
+              <a:t>• Gujarati audio alert soundbox</a:t>
+            </a:r>
+          </a:p>
+        </p:txBody>
+      </p:sp>
+      <p:sp>
+        <p:nvSpPr>
+          <p:cNvPr id="14" name="Rounded Rectangle 13"/>
+          <p:cNvSpPr/>
+          <p:nvPr/>
+        </p:nvSpPr>
+        <p:spPr>
+          <a:xfrm>
+            <a:off x="731520" y="5715000"/>
+            <a:ext cx="10698480" cy="594360"/>
+          </a:xfrm>
+          <a:prstGeom prst="roundRect">
+            <a:avLst/>
+          </a:prstGeom>
+          <a:solidFill>
+            <a:srgbClr val="F8FAFC"/>
+          </a:solidFill>
+          <a:ln w="12700">
+            <a:solidFill>
+              <a:srgbClr val="4F46E5"/>
+            </a:solidFill>
+          </a:ln>
+        </p:spPr>
+        <p:style>
+          <a:lnRef idx="1">
+            <a:schemeClr val="accent1"/>
+          </a:lnRef>
+          <a:fillRef idx="3">
+            <a:schemeClr val="accent1"/>
+          </a:fillRef>
+          <a:effectRef idx="2">
+            <a:schemeClr val="accent1"/>
+          </a:effectRef>
+          <a:fontRef idx="minor">
+            <a:schemeClr val="lt1"/>
+          </a:fontRef>
+        </p:style>
+        <p:txBody>
+          <a:bodyPr rtlCol="0" anchor="ctr" wrap="square"/>
+          <a:lstStyle/>
+          <a:p>
+            <a:pPr algn="ctr">
+              <a:defRPr b="1" sz="1150">
+                <a:solidFill>
+                  <a:srgbClr val="0F172A"/>
+                </a:solidFill>
+                <a:latin typeface="Calibri"/>
+              </a:defRPr>
+            </a:pPr>
+            <a:r>
+              <a:t>Figure 4: Assembled prototype / model of DineFlow AI | Live Production Cloud: https://dineflowai.duckdns.org</a:t>
             </a:r>
           </a:p>
         </p:txBody>

</xml_diff>

<commit_message>
docs(gtu): eliminate half-empty pages with comprehensive academic chapter content and fully stretch cover page to bottom margin
</commit_message>
<xml_diff>
--- a/docs/DineFlow_AI_GTU_Minor_Project_Presentation.pptx
+++ b/docs/DineFlow_AI_GTU_Minor_Project_Presentation.pptx
@@ -4083,7 +4083,7 @@
                         </a:defRPr>
                       </a:pPr>
                       <a:r>
-                        <a:t>Cloud Hosting Server</a:t>
+                        <a:t>AWS EC2 Cloud Server</a:t>
                       </a:r>
                     </a:p>
                   </a:txBody>
@@ -4107,7 +4107,7 @@
                         </a:defRPr>
                       </a:pPr>
                       <a:r>
-                        <a:t>AWS EC2 Ubuntu 24.04 LTS, 1 vCPU, 2GB RAM</a:t>
+                        <a:t>1 vCPU, 2GB RAM, 30GB SSD (Ubuntu 24.04)</a:t>
                       </a:r>
                     </a:p>
                   </a:txBody>
@@ -4155,7 +4155,7 @@
                         </a:defRPr>
                       </a:pPr>
                       <a:r>
-                        <a:t>₹ 0 (Free Tier / Self-Hosted)</a:t>
+                        <a:t>₹ 0 (Free Tier / Bootstrapped)</a:t>
                       </a:r>
                     </a:p>
                   </a:txBody>
@@ -4277,7 +4277,7 @@
                         </a:defRPr>
                       </a:pPr>
                       <a:r>
-                        <a:t>₹ 0 (Open Source)</a:t>
+                        <a:t>₹ 0 (Open-Source Stack)</a:t>
                       </a:r>
                     </a:p>
                   </a:txBody>
@@ -4351,7 +4351,7 @@
                         </a:defRPr>
                       </a:pPr>
                       <a:r>
-                        <a:t>58mm / 80mm USB Direct ESC/POS Printer</a:t>
+                        <a:t>58mm / 80mm USB Direct Thermal ESC/POS</a:t>
                       </a:r>
                     </a:p>
                   </a:txBody>
@@ -4399,7 +4399,7 @@
                         </a:defRPr>
                       </a:pPr>
                       <a:r>
-                        <a:t>₹ 2,800 (Prototype Unit)</a:t>
+                        <a:t>₹ 2,800 (Commercial HW)</a:t>
                       </a:r>
                     </a:p>
                   </a:txBody>
@@ -4449,7 +4449,7 @@
                         </a:defRPr>
                       </a:pPr>
                       <a:r>
-                        <a:t>Display Devices (POS &amp; KDS)</a:t>
+                        <a:t>Display Terminals</a:t>
                       </a:r>
                     </a:p>
                   </a:txBody>
@@ -4473,7 +4473,7 @@
                         </a:defRPr>
                       </a:pPr>
                       <a:r>
-                        <a:t>Existing PC / Touch Tablet / Smartphone</a:t>
+                        <a:t>Existing Laptops / Tablets / Android Phones</a:t>
                       </a:r>
                     </a:p>
                   </a:txBody>
@@ -4497,7 +4497,7 @@
                         </a:defRPr>
                       </a:pPr>
                       <a:r>
-                        <a:t>2</a:t>
+                        <a:t>3</a:t>
                       </a:r>
                     </a:p>
                   </a:txBody>
@@ -4521,7 +4521,7 @@
                         </a:defRPr>
                       </a:pPr>
                       <a:r>
-                        <a:t>₹ 0 (Existing Hardware)</a:t>
+                        <a:t>₹ 0 (Zero HW Lock-In)</a:t>
                       </a:r>
                     </a:p>
                   </a:txBody>
@@ -4595,7 +4595,7 @@
                         </a:defRPr>
                       </a:pPr>
                       <a:r>
-                        <a:t>DuckDNS Dynamic DNS + Let's Encrypt SSL</a:t>
+                        <a:t>DuckDNS Wildcard + Let's Encrypt SSL</a:t>
                       </a:r>
                     </a:p>
                   </a:txBody>
@@ -4643,7 +4643,7 @@
                         </a:defRPr>
                       </a:pPr>
                       <a:r>
-                        <a:t>₹ 0 (Free / Open)</a:t>
+                        <a:t>₹ 0 (Automated TLS 1.3)</a:t>
                       </a:r>
                     </a:p>
                   </a:txBody>
@@ -5177,7 +5177,7 @@
                         </a:defRPr>
                       </a:pPr>
                       <a:r>
-                        <a:t>Problem formulation, SRS, and architecture selection</a:t>
+                        <a:t>SRS preparation, system architecture, database ER modeling</a:t>
                       </a:r>
                     </a:p>
                   </a:txBody>
@@ -5275,7 +5275,7 @@
                         </a:defRPr>
                       </a:pPr>
                       <a:r>
-                        <a:t>Database design, multi-tenant auth, and POS terminal coding</a:t>
+                        <a:t>Database migration, multi-tenant auth &amp; Web POS billing terminal</a:t>
                       </a:r>
                     </a:p>
                   </a:txBody>
@@ -5373,7 +5373,7 @@
                         </a:defRPr>
                       </a:pPr>
                       <a:r>
-                        <a:t>KDS display, ESC/POS printing, and Gujarati voice soundbox</a:t>
+                        <a:t>KDS kitchen display, ESC/POS printing &amp; Gujarati voice soundbox</a:t>
                       </a:r>
                     </a:p>
                   </a:txBody>
@@ -5471,7 +5471,7 @@
                         </a:defRPr>
                       </a:pPr>
                       <a:r>
-                        <a:t>Testing, AWS EC2 deployment, documentation &amp; final PPT</a:t>
+                        <a:t>Testing, AWS EC2 deployment, documentation &amp; final presentation</a:t>
                       </a:r>
                     </a:p>
                   </a:txBody>
@@ -5495,7 +5495,7 @@
                         </a:defRPr>
                       </a:pPr>
                       <a:r>
-                        <a:t>Seminar 4 (Final)</a:t>
+                        <a:t>Seminar 4</a:t>
                       </a:r>
                     </a:p>
                   </a:txBody>
@@ -6393,7 +6393,7 @@
             <a:pPr algn="ctr">
               <a:defRPr b="1" sz="2800">
                 <a:solidFill>
-                  <a:srgbClr val="10B981"/>
+                  <a:srgbClr val="4F46E5"/>
                 </a:solidFill>
                 <a:latin typeface="Calibri"/>
               </a:defRPr>
@@ -6404,7 +6404,7 @@
           </a:p>
           <a:p>
             <a:pPr algn="ctr">
-              <a:defRPr b="1" sz="1100">
+              <a:defRPr b="1" sz="1150">
                 <a:solidFill>
                   <a:srgbClr val="0F172A"/>
                 </a:solidFill>
@@ -6474,7 +6474,7 @@
             <a:pPr algn="ctr">
               <a:defRPr b="1" sz="2800">
                 <a:solidFill>
-                  <a:srgbClr val="10B981"/>
+                  <a:srgbClr val="4F46E5"/>
                 </a:solidFill>
                 <a:latin typeface="Calibri"/>
               </a:defRPr>
@@ -6485,7 +6485,7 @@
           </a:p>
           <a:p>
             <a:pPr algn="ctr">
-              <a:defRPr b="1" sz="1100">
+              <a:defRPr b="1" sz="1150">
                 <a:solidFill>
                   <a:srgbClr val="0F172A"/>
                 </a:solidFill>
@@ -6555,7 +6555,7 @@
             <a:pPr algn="ctr">
               <a:defRPr b="1" sz="2800">
                 <a:solidFill>
-                  <a:srgbClr val="10B981"/>
+                  <a:srgbClr val="4F46E5"/>
                 </a:solidFill>
                 <a:latin typeface="Calibri"/>
               </a:defRPr>
@@ -6566,7 +6566,7 @@
           </a:p>
           <a:p>
             <a:pPr algn="ctr">
-              <a:defRPr b="1" sz="1100">
+              <a:defRPr b="1" sz="1150">
                 <a:solidFill>
                   <a:srgbClr val="0F172A"/>
                 </a:solidFill>
@@ -6636,7 +6636,7 @@
             <a:pPr algn="ctr">
               <a:defRPr b="1" sz="2800">
                 <a:solidFill>
-                  <a:srgbClr val="10B981"/>
+                  <a:srgbClr val="4F46E5"/>
                 </a:solidFill>
                 <a:latin typeface="Calibri"/>
               </a:defRPr>
@@ -6647,7 +6647,7 @@
           </a:p>
           <a:p>
             <a:pPr algn="ctr">
-              <a:defRPr b="1" sz="1100">
+              <a:defRPr b="1" sz="1150">
                 <a:solidFill>
                   <a:srgbClr val="0F172A"/>
                 </a:solidFill>
@@ -6675,28 +6675,47 @@
       </p:sp>
       <p:sp>
         <p:nvSpPr>
-          <p:cNvPr id="12" name="TextBox 11"/>
-          <p:cNvSpPr txBox="1"/>
+          <p:cNvPr id="12" name="Rounded Rectangle 11"/>
+          <p:cNvSpPr/>
           <p:nvPr/>
         </p:nvSpPr>
         <p:spPr>
           <a:xfrm>
             <a:off x="914400" y="3749039"/>
-            <a:ext cx="10362895" cy="2560320"/>
-          </a:xfrm>
-          <a:prstGeom prst="rect">
-            <a:avLst/>
-          </a:prstGeom>
-          <a:noFill/>
-        </p:spPr>
-        <p:txBody>
-          <a:bodyPr wrap="square">
-            <a:spAutoFit/>
-          </a:bodyPr>
-          <a:lstStyle/>
-          <a:p>
-            <a:pPr>
-              <a:defRPr b="1" sz="1250">
+            <a:ext cx="10362895" cy="2468880"/>
+          </a:xfrm>
+          <a:prstGeom prst="roundRect">
+            <a:avLst/>
+          </a:prstGeom>
+          <a:solidFill>
+            <a:srgbClr val="F8FAFC"/>
+          </a:solidFill>
+          <a:ln>
+            <a:solidFill>
+              <a:srgbClr val="E2E8F0"/>
+            </a:solidFill>
+          </a:ln>
+        </p:spPr>
+        <p:style>
+          <a:lnRef idx="1">
+            <a:schemeClr val="accent1"/>
+          </a:lnRef>
+          <a:fillRef idx="3">
+            <a:schemeClr val="accent1"/>
+          </a:fillRef>
+          <a:effectRef idx="2">
+            <a:schemeClr val="accent1"/>
+          </a:effectRef>
+          <a:fontRef idx="minor">
+            <a:schemeClr val="lt1"/>
+          </a:fontRef>
+        </p:style>
+        <p:txBody>
+          <a:bodyPr rtlCol="0" anchor="ctr" wrap="square"/>
+          <a:lstStyle/>
+          <a:p>
+            <a:pPr algn="ctr">
+              <a:defRPr b="1" sz="1300">
                 <a:solidFill>
                   <a:srgbClr val="4F46E5"/>
                 </a:solidFill>
@@ -6704,7 +6723,7 @@
               </a:defRPr>
             </a:pPr>
             <a:r>
-              <a:t>VERIFIED TEST SUITES (Executed via Automated PHPUnit &amp; Live Stress Testing):</a:t>
+              <a:t>TEST SUITE HIGHLIGHTS &amp; VERIFICATION:</a:t>
             </a:r>
           </a:p>
           <a:p>
@@ -8206,7 +8225,7 @@
           </a:p>
           <a:p>
             <a:pPr>
-              <a:defRPr b="1" sz="1200">
+              <a:defRPr b="1" sz="1100">
                 <a:solidFill>
                   <a:srgbClr val="4F46E5"/>
                 </a:solidFill>
@@ -8218,8 +8237,9 @@
             </a:r>
           </a:p>
           <a:p>
+            <a:br/>
             <a:pPr>
-              <a:defRPr sz="1150">
+              <a:defRPr sz="1100">
                 <a:solidFill>
                   <a:srgbClr val="1E293B"/>
                 </a:solidFill>
@@ -8299,7 +8319,7 @@
           </a:p>
           <a:p>
             <a:pPr>
-              <a:defRPr b="1" sz="1200">
+              <a:defRPr b="1" sz="1100">
                 <a:solidFill>
                   <a:srgbClr val="4F46E5"/>
                 </a:solidFill>
@@ -8311,8 +8331,9 @@
             </a:r>
           </a:p>
           <a:p>
+            <a:br/>
             <a:pPr>
-              <a:defRPr sz="1150">
+              <a:defRPr sz="1100">
                 <a:solidFill>
                   <a:srgbClr val="1E293B"/>
                 </a:solidFill>
@@ -8392,7 +8413,7 @@
           </a:p>
           <a:p>
             <a:pPr>
-              <a:defRPr b="1" sz="1200">
+              <a:defRPr b="1" sz="1100">
                 <a:solidFill>
                   <a:srgbClr val="4F46E5"/>
                 </a:solidFill>
@@ -8404,8 +8425,9 @@
             </a:r>
           </a:p>
           <a:p>
+            <a:br/>
             <a:pPr>
-              <a:defRPr sz="1150">
+              <a:defRPr sz="1100">
                 <a:solidFill>
                   <a:srgbClr val="1E293B"/>
                 </a:solidFill>
@@ -8561,7 +8583,7 @@
               </a:defRPr>
             </a:pPr>
             <a:r>
-              <a:t>References and Thank You</a:t>
+              <a:t>Thank You &amp; Discussion</a:t>
             </a:r>
           </a:p>
         </p:txBody>
@@ -8652,115 +8674,14 @@
       </p:sp>
       <p:sp>
         <p:nvSpPr>
-          <p:cNvPr id="8" name="TextBox 7"/>
-          <p:cNvSpPr txBox="1"/>
-          <p:nvPr/>
-        </p:nvSpPr>
-        <p:spPr>
-          <a:xfrm>
-            <a:off x="914400" y="1463040"/>
-            <a:ext cx="5486400" cy="4754880"/>
-          </a:xfrm>
-          <a:prstGeom prst="rect">
-            <a:avLst/>
-          </a:prstGeom>
-          <a:noFill/>
-        </p:spPr>
-        <p:txBody>
-          <a:bodyPr wrap="square">
-            <a:spAutoFit/>
-          </a:bodyPr>
-          <a:lstStyle/>
-          <a:p>
-            <a:pPr>
-              <a:defRPr b="1" sz="1300">
-                <a:solidFill>
-                  <a:srgbClr val="4F46E5"/>
-                </a:solidFill>
-                <a:latin typeface="Calibri"/>
-              </a:defRPr>
-            </a:pPr>
-            <a:r>
-              <a:t>ACADEMIC REFERENCES (APA 7th Edition):</a:t>
-            </a:r>
-          </a:p>
-          <a:p>
-            <a:pPr>
-              <a:defRPr sz="1050">
-                <a:solidFill>
-                  <a:srgbClr val="1E293B"/>
-                </a:solidFill>
-                <a:latin typeface="Calibri"/>
-              </a:defRPr>
-            </a:pPr>
-            <a:r>
-              <a:t>• Gujarat Technological University. (2026). Diploma Engineering Minor Project Syllabus (Subject Code: DI05000341). GTU Academic Board.</a:t>
-            </a:r>
-          </a:p>
-          <a:p>
-            <a:pPr>
-              <a:defRPr sz="1050">
-                <a:solidFill>
-                  <a:srgbClr val="1E293B"/>
-                </a:solidFill>
-                <a:latin typeface="Calibri"/>
-              </a:defRPr>
-            </a:pPr>
-            <a:r>
-              <a:t>• National Restaurant Association of India. (2024). India Food Services Report: Technology Adoption in Hospitality Sector. NRAI Publications.</a:t>
-            </a:r>
-          </a:p>
-          <a:p>
-            <a:pPr>
-              <a:defRPr sz="1050">
-                <a:solidFill>
-                  <a:srgbClr val="1E293B"/>
-                </a:solidFill>
-                <a:latin typeface="Calibri"/>
-              </a:defRPr>
-            </a:pPr>
-            <a:r>
-              <a:t>• Otwell, T. (2024). Laravel 11: The PHP Framework for Web Artisans. Taylor Otwell &amp; Laravel Core Team.</a:t>
-            </a:r>
-          </a:p>
-          <a:p>
-            <a:pPr>
-              <a:defRPr sz="1050">
-                <a:solidFill>
-                  <a:srgbClr val="1E293B"/>
-                </a:solidFill>
-                <a:latin typeface="Calibri"/>
-              </a:defRPr>
-            </a:pPr>
-            <a:r>
-              <a:t>• Fielding, R. T. (2000). Architectural Styles and the Design of Network-based Software Architectures. University of California, Irvine.</a:t>
-            </a:r>
-          </a:p>
-          <a:p>
-            <a:pPr>
-              <a:defRPr sz="1050">
-                <a:solidFill>
-                  <a:srgbClr val="1E293B"/>
-                </a:solidFill>
-                <a:latin typeface="Calibri"/>
-              </a:defRPr>
-            </a:pPr>
-            <a:r>
-              <a:t>• World Wide Web Consortium. (2023). Progressive Web Apps Architecture &amp; Service Workers Specification. W3C Recommendation.</a:t>
-            </a:r>
-          </a:p>
-        </p:txBody>
-      </p:sp>
-      <p:sp>
-        <p:nvSpPr>
-          <p:cNvPr id="9" name="Rounded Rectangle 8"/>
+          <p:cNvPr id="8" name="Rounded Rectangle 7"/>
           <p:cNvSpPr/>
           <p:nvPr/>
         </p:nvSpPr>
         <p:spPr>
           <a:xfrm>
-            <a:off x="6766560" y="1463040"/>
-            <a:ext cx="4480560" cy="4572000"/>
+            <a:off x="2286000" y="1463040"/>
+            <a:ext cx="7619695" cy="4572000"/>
           </a:xfrm>
           <a:prstGeom prst="roundRect">
             <a:avLst/>
@@ -10056,9 +9977,9 @@
           <a:lstStyle/>
           <a:p>
             <a:pPr algn="ctr">
-              <a:defRPr b="1" sz="1350">
-                <a:solidFill>
-                  <a:srgbClr val="4F46E5"/>
+              <a:defRPr b="1" sz="1400">
+                <a:solidFill>
+                  <a:srgbClr val="0F172A"/>
                 </a:solidFill>
                 <a:latin typeface="Calibri"/>
               </a:defRPr>
@@ -10068,6 +9989,7 @@
             </a:r>
           </a:p>
           <a:p>
+            <a:br/>
             <a:pPr>
               <a:defRPr sz="1150">
                 <a:solidFill>
@@ -10132,9 +10054,9 @@
           <a:lstStyle/>
           <a:p>
             <a:pPr algn="ctr">
-              <a:defRPr b="1" sz="1350">
-                <a:solidFill>
-                  <a:srgbClr val="4F46E5"/>
+              <a:defRPr b="1" sz="1400">
+                <a:solidFill>
+                  <a:srgbClr val="0F172A"/>
                 </a:solidFill>
                 <a:latin typeface="Calibri"/>
               </a:defRPr>
@@ -10144,6 +10066,7 @@
             </a:r>
           </a:p>
           <a:p>
+            <a:br/>
             <a:pPr>
               <a:defRPr sz="1150">
                 <a:solidFill>
@@ -10208,9 +10131,9 @@
           <a:lstStyle/>
           <a:p>
             <a:pPr algn="ctr">
-              <a:defRPr b="1" sz="1350">
-                <a:solidFill>
-                  <a:srgbClr val="4F46E5"/>
+              <a:defRPr b="1" sz="1400">
+                <a:solidFill>
+                  <a:srgbClr val="0F172A"/>
                 </a:solidFill>
                 <a:latin typeface="Calibri"/>
               </a:defRPr>
@@ -10220,6 +10143,7 @@
             </a:r>
           </a:p>
           <a:p>
+            <a:br/>
             <a:pPr>
               <a:defRPr sz="1150">
                 <a:solidFill>
@@ -10377,7 +10301,7 @@
               </a:defRPr>
             </a:pPr>
             <a:r>
-              <a:t>Literature Survey and Research Gap</a:t>
+              <a:t>Literature Survey &amp; Market Research</a:t>
             </a:r>
           </a:p>
         </p:txBody>
@@ -10476,7 +10400,7 @@
         </p:nvGraphicFramePr>
         <p:xfrm>
           <a:off x="914400" y="1371600"/>
-          <a:ext cx="10332720" cy="3474720"/>
+          <a:ext cx="10332720" cy="4114800"/>
         </p:xfrm>
         <a:graphic>
           <a:graphicData uri="http://schemas.openxmlformats.org/drawingml/2006/table">
@@ -10485,12 +10409,13 @@
                 <a:tableStyleId>{5C22544A-7EE6-4342-B048-85BDC9FD1C3A}</a:tableStyleId>
               </a:tblPr>
               <a:tblGrid>
-                <a:gridCol w="2286000"/>
                 <a:gridCol w="2011680"/>
-                <a:gridCol w="3474720"/>
-                <a:gridCol w="2560320"/>
+                <a:gridCol w="2011680"/>
+                <a:gridCol w="2103120"/>
+                <a:gridCol w="2103120"/>
+                <a:gridCol w="2103120"/>
               </a:tblGrid>
-              <a:tr h="694944">
+              <a:tr h="822960">
                 <a:tc>
                   <a:txBody>
                     <a:bodyPr/>
@@ -10505,7 +10430,7 @@
                         </a:defRPr>
                       </a:pPr>
                       <a:r>
-                        <a:t>Existing System / Source</a:t>
+                        <a:t>System Analyzed</a:t>
                       </a:r>
                     </a:p>
                   </a:txBody>
@@ -10529,7 +10454,7 @@
                         </a:defRPr>
                       </a:pPr>
                       <a:r>
-                        <a:t>Core Technology</a:t>
+                        <a:t>Platform &amp; Tech</a:t>
                       </a:r>
                     </a:p>
                   </a:txBody>
@@ -10553,7 +10478,7 @@
                         </a:defRPr>
                       </a:pPr>
                       <a:r>
-                        <a:t>Working Method</a:t>
+                        <a:t>Core Strengths</a:t>
                       </a:r>
                     </a:p>
                   </a:txBody>
@@ -10577,7 +10502,31 @@
                         </a:defRPr>
                       </a:pPr>
                       <a:r>
-                        <a:t>Identified Gap / Limitation</a:t>
+                        <a:t>Identified Weakness</a:t>
+                      </a:r>
+                    </a:p>
+                  </a:txBody>
+                  <a:tcPr>
+                    <a:solidFill>
+                      <a:srgbClr val="4F46E5"/>
+                    </a:solidFill>
+                  </a:tcPr>
+                </a:tc>
+                <a:tc>
+                  <a:txBody>
+                    <a:bodyPr/>
+                    <a:lstStyle/>
+                    <a:p>
+                      <a:pPr>
+                        <a:defRPr b="1" sz="1100">
+                          <a:solidFill>
+                            <a:srgbClr val="FFFFFF"/>
+                          </a:solidFill>
+                          <a:latin typeface="Calibri"/>
+                        </a:defRPr>
+                      </a:pPr>
+                      <a:r>
+                        <a:t>Cost Barrier</a:t>
                       </a:r>
                     </a:p>
                   </a:txBody>
@@ -10588,7 +10537,7 @@
                   </a:tcPr>
                 </a:tc>
               </a:tr>
-              <a:tr h="694944">
+              <a:tr h="822960">
                 <a:tc>
                   <a:txBody>
                     <a:bodyPr/>
@@ -10603,7 +10552,7 @@
                         </a:defRPr>
                       </a:pPr>
                       <a:r>
-                        <a:t>Toast POS (USA, 2023)</a:t>
+                        <a:t>Toast POS (US)</a:t>
                       </a:r>
                     </a:p>
                   </a:txBody>
@@ -10627,7 +10576,7 @@
                         </a:defRPr>
                       </a:pPr>
                       <a:r>
-                        <a:t>Android Proprietary</a:t>
+                        <a:t>Android Cloud</a:t>
                       </a:r>
                     </a:p>
                   </a:txBody>
@@ -10651,7 +10600,7 @@
                         </a:defRPr>
                       </a:pPr>
                       <a:r>
-                        <a:t>Cloud POS for large chains</a:t>
+                        <a:t>Handheld ordering</a:t>
                       </a:r>
                     </a:p>
                   </a:txBody>
@@ -10675,33 +10624,7 @@
                         </a:defRPr>
                       </a:pPr>
                       <a:r>
-                        <a:t>Expensive ($69-$165/mo), proprietary hardware lock-in, zero Indian UPI/GST.</a:t>
-                      </a:r>
-                    </a:p>
-                  </a:txBody>
-                  <a:tcPr>
-                    <a:solidFill>
-                      <a:srgbClr val="F8FAFC"/>
-                    </a:solidFill>
-                  </a:tcPr>
-                </a:tc>
-              </a:tr>
-              <a:tr h="694944">
-                <a:tc>
-                  <a:txBody>
-                    <a:bodyPr/>
-                    <a:lstStyle/>
-                    <a:p>
-                      <a:pPr>
-                        <a:defRPr sz="1050">
-                          <a:solidFill>
-                            <a:srgbClr val="1E293B"/>
-                          </a:solidFill>
-                          <a:latin typeface="Calibri"/>
-                        </a:defRPr>
-                      </a:pPr>
-                      <a:r>
-                        <a:t>Petpooja (India, 2024)</a:t>
+                        <a:t>Proprietary HW lock-in; no Indian UPI/GST</a:t>
                       </a:r>
                     </a:p>
                   </a:txBody>
@@ -10725,7 +10648,33 @@
                         </a:defRPr>
                       </a:pPr>
                       <a:r>
-                        <a:t>Desktop Windows App</a:t>
+                        <a:t>High ($1,000+ HW + $69/mo)</a:t>
+                      </a:r>
+                    </a:p>
+                  </a:txBody>
+                  <a:tcPr>
+                    <a:solidFill>
+                      <a:srgbClr val="F8FAFC"/>
+                    </a:solidFill>
+                  </a:tcPr>
+                </a:tc>
+              </a:tr>
+              <a:tr h="822960">
+                <a:tc>
+                  <a:txBody>
+                    <a:bodyPr/>
+                    <a:lstStyle/>
+                    <a:p>
+                      <a:pPr>
+                        <a:defRPr sz="1050">
+                          <a:solidFill>
+                            <a:srgbClr val="1E293B"/>
+                          </a:solidFill>
+                          <a:latin typeface="Calibri"/>
+                        </a:defRPr>
+                      </a:pPr>
+                      <a:r>
+                        <a:t>Petpooja (India)</a:t>
                       </a:r>
                     </a:p>
                   </a:txBody>
@@ -10749,7 +10698,7 @@
                         </a:defRPr>
                       </a:pPr>
                       <a:r>
-                        <a:t>Local client-server billing</a:t>
+                        <a:t>Windows Desktop Client</a:t>
                       </a:r>
                     </a:p>
                   </a:txBody>
@@ -10773,7 +10722,7 @@
                         </a:defRPr>
                       </a:pPr>
                       <a:r>
-                        <a:t>Heavy desktop client install required, complex remote sync, slow QR ordering.</a:t>
+                        <a:t>Widely adopted in India</a:t>
                       </a:r>
                     </a:p>
                   </a:txBody>
@@ -10783,8 +10732,6 @@
                     </a:solidFill>
                   </a:tcPr>
                 </a:tc>
-              </a:tr>
-              <a:tr h="694944">
                 <a:tc>
                   <a:txBody>
                     <a:bodyPr/>
@@ -10799,7 +10746,57 @@
                         </a:defRPr>
                       </a:pPr>
                       <a:r>
-                        <a:t>POSist / Restroworks (2023)</a:t>
+                        <a:t>Heavy PC install; slow web QR sync</a:t>
+                      </a:r>
+                    </a:p>
+                  </a:txBody>
+                  <a:tcPr>
+                    <a:solidFill>
+                      <a:srgbClr val="F8FAFC"/>
+                    </a:solidFill>
+                  </a:tcPr>
+                </a:tc>
+                <a:tc>
+                  <a:txBody>
+                    <a:bodyPr/>
+                    <a:lstStyle/>
+                    <a:p>
+                      <a:pPr>
+                        <a:defRPr sz="1050">
+                          <a:solidFill>
+                            <a:srgbClr val="1E293B"/>
+                          </a:solidFill>
+                          <a:latin typeface="Calibri"/>
+                        </a:defRPr>
+                      </a:pPr>
+                      <a:r>
+                        <a:t>Moderate (₹10,000/yr + Add-ons)</a:t>
+                      </a:r>
+                    </a:p>
+                  </a:txBody>
+                  <a:tcPr>
+                    <a:solidFill>
+                      <a:srgbClr val="F8FAFC"/>
+                    </a:solidFill>
+                  </a:tcPr>
+                </a:tc>
+              </a:tr>
+              <a:tr h="822960">
+                <a:tc>
+                  <a:txBody>
+                    <a:bodyPr/>
+                    <a:lstStyle/>
+                    <a:p>
+                      <a:pPr>
+                        <a:defRPr sz="1050">
+                          <a:solidFill>
+                            <a:srgbClr val="1E293B"/>
+                          </a:solidFill>
+                          <a:latin typeface="Calibri"/>
+                        </a:defRPr>
+                      </a:pPr>
+                      <a:r>
+                        <a:t>POSist / Restroworks</a:t>
                       </a:r>
                     </a:p>
                   </a:txBody>
@@ -10847,7 +10844,7 @@
                         </a:defRPr>
                       </a:pPr>
                       <a:r>
-                        <a:t>Multi-brand centralized ERP</a:t>
+                        <a:t>Multi-chain reporting</a:t>
                       </a:r>
                     </a:p>
                   </a:txBody>
@@ -10871,33 +10868,7 @@
                         </a:defRPr>
                       </a:pPr>
                       <a:r>
-                        <a:t>High subscription cost, steep learning curve, no regional Gujarati voice soundbox.</a:t>
-                      </a:r>
-                    </a:p>
-                  </a:txBody>
-                  <a:tcPr>
-                    <a:solidFill>
-                      <a:srgbClr val="F8FAFC"/>
-                    </a:solidFill>
-                  </a:tcPr>
-                </a:tc>
-              </a:tr>
-              <a:tr h="694944">
-                <a:tc>
-                  <a:txBody>
-                    <a:bodyPr/>
-                    <a:lstStyle/>
-                    <a:p>
-                      <a:pPr>
-                        <a:defRPr sz="1050">
-                          <a:solidFill>
-                            <a:srgbClr val="1E293B"/>
-                          </a:solidFill>
-                          <a:latin typeface="Calibri"/>
-                        </a:defRPr>
-                      </a:pPr>
-                      <a:r>
-                        <a:t>Manual Paper Tokens (Traditional)</a:t>
+                        <a:t>Steep learning curve; complex for cafes</a:t>
                       </a:r>
                     </a:p>
                   </a:txBody>
@@ -10921,7 +10892,33 @@
                         </a:defRPr>
                       </a:pPr>
                       <a:r>
-                        <a:t>Pen &amp; Paper / Token</a:t>
+                        <a:t>Very High (₹25,000/yr minimum)</a:t>
+                      </a:r>
+                    </a:p>
+                  </a:txBody>
+                  <a:tcPr>
+                    <a:solidFill>
+                      <a:srgbClr val="F8FAFC"/>
+                    </a:solidFill>
+                  </a:tcPr>
+                </a:tc>
+              </a:tr>
+              <a:tr h="822960">
+                <a:tc>
+                  <a:txBody>
+                    <a:bodyPr/>
+                    <a:lstStyle/>
+                    <a:p>
+                      <a:pPr>
+                        <a:defRPr sz="1050">
+                          <a:solidFill>
+                            <a:srgbClr val="1E293B"/>
+                          </a:solidFill>
+                          <a:latin typeface="Calibri"/>
+                        </a:defRPr>
+                      </a:pPr>
+                      <a:r>
+                        <a:t>Manual Paper Tokens</a:t>
                       </a:r>
                     </a:p>
                   </a:txBody>
@@ -10945,7 +10942,7 @@
                         </a:defRPr>
                       </a:pPr>
                       <a:r>
-                        <a:t>Handwritten KOT slips</a:t>
+                        <a:t>Paper &amp; Notepad</a:t>
                       </a:r>
                     </a:p>
                   </a:txBody>
@@ -10969,7 +10966,55 @@
                         </a:defRPr>
                       </a:pPr>
                       <a:r>
-                        <a:t>High error rate (15-20%), lost slips, zero inventory visibility, zero analytics.</a:t>
+                        <a:t>Zero digital investment</a:t>
+                      </a:r>
+                    </a:p>
+                  </a:txBody>
+                  <a:tcPr>
+                    <a:solidFill>
+                      <a:srgbClr val="F8FAFC"/>
+                    </a:solidFill>
+                  </a:tcPr>
+                </a:tc>
+                <a:tc>
+                  <a:txBody>
+                    <a:bodyPr/>
+                    <a:lstStyle/>
+                    <a:p>
+                      <a:pPr>
+                        <a:defRPr sz="1050">
+                          <a:solidFill>
+                            <a:srgbClr val="1E293B"/>
+                          </a:solidFill>
+                          <a:latin typeface="Calibri"/>
+                        </a:defRPr>
+                      </a:pPr>
+                      <a:r>
+                        <a:t>15-20% errors, lost KOTs, zero stock math</a:t>
+                      </a:r>
+                    </a:p>
+                  </a:txBody>
+                  <a:tcPr>
+                    <a:solidFill>
+                      <a:srgbClr val="F8FAFC"/>
+                    </a:solidFill>
+                  </a:tcPr>
+                </a:tc>
+                <a:tc>
+                  <a:txBody>
+                    <a:bodyPr/>
+                    <a:lstStyle/>
+                    <a:p>
+                      <a:pPr>
+                        <a:defRPr sz="1050">
+                          <a:solidFill>
+                            <a:srgbClr val="1E293B"/>
+                          </a:solidFill>
+                          <a:latin typeface="Calibri"/>
+                        </a:defRPr>
+                      </a:pPr>
+                      <a:r>
+                        <a:t>Hidden (₹10,000/yr printing waste)</a:t>
                       </a:r>
                     </a:p>
                   </a:txBody>
@@ -10992,8 +11037,8 @@
         </p:nvSpPr>
         <p:spPr>
           <a:xfrm>
-            <a:off x="914400" y="5120640"/>
-            <a:ext cx="10362895" cy="1280160"/>
+            <a:off x="914400" y="5669280"/>
+            <a:ext cx="10362895" cy="822960"/>
           </a:xfrm>
           <a:prstGeom prst="rect">
             <a:avLst/>
@@ -11007,28 +11052,15 @@
           <a:lstStyle/>
           <a:p>
             <a:pPr>
-              <a:defRPr b="1" sz="1250">
-                <a:solidFill>
-                  <a:srgbClr val="10B981"/>
+              <a:defRPr b="1" sz="1100">
+                <a:solidFill>
+                  <a:srgbClr val="4F46E5"/>
                 </a:solidFill>
                 <a:latin typeface="Calibri"/>
               </a:defRPr>
             </a:pPr>
             <a:r>
-              <a:t>RESEARCH GAP IDENTIFIED:</a:t>
-            </a:r>
-          </a:p>
-          <a:p>
-            <a:pPr>
-              <a:defRPr sz="1150">
-                <a:solidFill>
-                  <a:srgbClr val="1E293B"/>
-                </a:solidFill>
-                <a:latin typeface="Calibri"/>
-              </a:defRPr>
-            </a:pPr>
-            <a:r>
-              <a:t>Existing solutions are either expensive and locked to proprietary hardware or limited to clunky offline desktop software. There is a clear market need for an affordable, hardware-agnostic Cloud PWA POS combining instantaneous QR table ordering, live KDS, raw-material recipe costing, and regional Gujarati voice alerts.</a:t>
+              <a:t>RESEARCH GAP: Small eateries lack an affordable, zero-install Cloud PWA POS combining sub-3s billing, contactless QR ordering, recipe BOM depletion, and Gujarati audio alerts without proprietary hardware lock-in.</a:t>
             </a:r>
           </a:p>
         </p:txBody>
@@ -11168,7 +11200,7 @@
               </a:defRPr>
             </a:pPr>
             <a:r>
-              <a:t>Alternative Solutions and Selection</a:t>
+              <a:t>Comparative Analysis of Alternative Solutions</a:t>
             </a:r>
           </a:p>
         </p:txBody>
@@ -11277,9 +11309,9 @@
               </a:tblPr>
               <a:tblGrid>
                 <a:gridCol w="2286000"/>
-                <a:gridCol w="2560320"/>
-                <a:gridCol w="2560320"/>
-                <a:gridCol w="2926080"/>
+                <a:gridCol w="2651760"/>
+                <a:gridCol w="2651760"/>
+                <a:gridCol w="2743200"/>
               </a:tblGrid>
               <a:tr h="694944">
                 <a:tc>
@@ -11288,7 +11320,7 @@
                     <a:lstStyle/>
                     <a:p>
                       <a:pPr>
-                        <a:defRPr b="1" sz="1050">
+                        <a:defRPr b="1" sz="1100">
                           <a:solidFill>
                             <a:srgbClr val="FFFFFF"/>
                           </a:solidFill>
@@ -11296,7 +11328,7 @@
                         </a:defRPr>
                       </a:pPr>
                       <a:r>
-                        <a:t>Comparison Criteria</a:t>
+                        <a:t>Evaluation Metric</a:t>
                       </a:r>
                     </a:p>
                   </a:txBody>
@@ -11312,7 +11344,7 @@
                     <a:lstStyle/>
                     <a:p>
                       <a:pPr>
-                        <a:defRPr b="1" sz="1050">
+                        <a:defRPr b="1" sz="1100">
                           <a:solidFill>
                             <a:srgbClr val="FFFFFF"/>
                           </a:solidFill>
@@ -11320,7 +11352,7 @@
                         </a:defRPr>
                       </a:pPr>
                       <a:r>
-                        <a:t>Option A: Desktop App (C# / .NET)</a:t>
+                        <a:t>Option A: Desktop Native</a:t>
                       </a:r>
                     </a:p>
                   </a:txBody>
@@ -11336,7 +11368,7 @@
                     <a:lstStyle/>
                     <a:p>
                       <a:pPr>
-                        <a:defRPr b="1" sz="1050">
+                        <a:defRPr b="1" sz="1100">
                           <a:solidFill>
                             <a:srgbClr val="FFFFFF"/>
                           </a:solidFill>
@@ -11344,7 +11376,7 @@
                         </a:defRPr>
                       </a:pPr>
                       <a:r>
-                        <a:t>Option B: Dedicated Hardware Terminal</a:t>
+                        <a:t>Option B: Dedicated HW</a:t>
                       </a:r>
                     </a:p>
                   </a:txBody>
@@ -11360,7 +11392,7 @@
                     <a:lstStyle/>
                     <a:p>
                       <a:pPr>
-                        <a:defRPr b="1" sz="1050">
+                        <a:defRPr b="1" sz="1100">
                           <a:solidFill>
                             <a:srgbClr val="FFFFFF"/>
                           </a:solidFill>
@@ -11368,7 +11400,7 @@
                         </a:defRPr>
                       </a:pPr>
                       <a:r>
-                        <a:t>Option C (Selected): Cloud PWA (Laravel + JS)</a:t>
+                        <a:t>Option C: Cloud PWA (DineFlow AI)</a:t>
                       </a:r>
                     </a:p>
                   </a:txBody>
@@ -12065,9 +12097,9 @@
           <a:solidFill>
             <a:srgbClr val="F8FAFC"/>
           </a:solidFill>
-          <a:ln w="19050">
+          <a:ln>
             <a:solidFill>
-              <a:srgbClr val="4F46E5"/>
+              <a:srgbClr val="E2E8F0"/>
             </a:solidFill>
           </a:ln>
         </p:spPr>
@@ -12102,6 +12134,7 @@
             </a:r>
           </a:p>
           <a:p>
+            <a:br/>
             <a:pPr>
               <a:defRPr sz="1200">
                 <a:solidFill>
@@ -12145,9 +12178,9 @@
           <a:solidFill>
             <a:srgbClr val="F8FAFC"/>
           </a:solidFill>
-          <a:ln w="19050">
+          <a:ln>
             <a:solidFill>
-              <a:srgbClr val="4F46E5"/>
+              <a:srgbClr val="E2E8F0"/>
             </a:solidFill>
           </a:ln>
         </p:spPr>
@@ -12182,6 +12215,7 @@
             </a:r>
           </a:p>
           <a:p>
+            <a:br/>
             <a:pPr>
               <a:defRPr sz="1200">
                 <a:solidFill>
@@ -12229,9 +12263,9 @@
           <a:solidFill>
             <a:srgbClr val="F8FAFC"/>
           </a:solidFill>
-          <a:ln w="19050">
+          <a:ln>
             <a:solidFill>
-              <a:srgbClr val="4F46E5"/>
+              <a:srgbClr val="E2E8F0"/>
             </a:solidFill>
           </a:ln>
         </p:spPr>
@@ -12266,6 +12300,7 @@
             </a:r>
           </a:p>
           <a:p>
+            <a:br/>
             <a:pPr>
               <a:defRPr sz="1200">
                 <a:solidFill>
@@ -12292,42 +12327,6 @@
             <a:br/>
             <a:r>
               <a:t>• Customer Digital Receipt</a:t>
-            </a:r>
-          </a:p>
-        </p:txBody>
-      </p:sp>
-      <p:sp>
-        <p:nvSpPr>
-          <p:cNvPr id="11" name="TextBox 10"/>
-          <p:cNvSpPr txBox="1"/>
-          <p:nvPr/>
-        </p:nvSpPr>
-        <p:spPr>
-          <a:xfrm>
-            <a:off x="914400" y="5943600"/>
-            <a:ext cx="10362895" cy="548640"/>
-          </a:xfrm>
-          <a:prstGeom prst="rect">
-            <a:avLst/>
-          </a:prstGeom>
-          <a:noFill/>
-        </p:spPr>
-        <p:txBody>
-          <a:bodyPr wrap="none">
-            <a:spAutoFit/>
-          </a:bodyPr>
-          <a:lstStyle/>
-          <a:p>
-            <a:pPr>
-              <a:defRPr sz="1100">
-                <a:solidFill>
-                  <a:srgbClr val="64748B"/>
-                </a:solidFill>
-                <a:latin typeface="Calibri"/>
-              </a:defRPr>
-            </a:pPr>
-            <a:r>
-              <a:t>System Data Flow: Input captures customer/cashier orders → Core validates stock &amp; tenant isolation → Output dispatches KOT &amp; bill simultaneously in &lt;200ms.</a:t>
             </a:r>
           </a:p>
         </p:txBody>
@@ -12467,7 +12466,7 @@
               </a:defRPr>
             </a:pPr>
             <a:r>
-              <a:t>Detailed System Architecture Diagram</a:t>
+              <a:t>Database Design &amp; Entity Architecture</a:t>
             </a:r>
           </a:p>
         </p:txBody>
@@ -12558,40 +12557,59 @@
       </p:sp>
       <p:sp>
         <p:nvSpPr>
-          <p:cNvPr id="8" name="TextBox 7"/>
-          <p:cNvSpPr txBox="1"/>
+          <p:cNvPr id="8" name="Rounded Rectangle 7"/>
+          <p:cNvSpPr/>
           <p:nvPr/>
         </p:nvSpPr>
         <p:spPr>
           <a:xfrm>
             <a:off x="914400" y="1463040"/>
-            <a:ext cx="10362895" cy="4754880"/>
-          </a:xfrm>
-          <a:prstGeom prst="rect">
-            <a:avLst/>
-          </a:prstGeom>
-          <a:noFill/>
-        </p:spPr>
-        <p:txBody>
-          <a:bodyPr wrap="square">
-            <a:spAutoFit/>
-          </a:bodyPr>
-          <a:lstStyle/>
-          <a:p/>
-          <a:p>
-            <a:pPr>
+            <a:ext cx="3291840" cy="4572000"/>
+          </a:xfrm>
+          <a:prstGeom prst="roundRect">
+            <a:avLst/>
+          </a:prstGeom>
+          <a:solidFill>
+            <a:srgbClr val="F8FAFC"/>
+          </a:solidFill>
+          <a:ln>
+            <a:solidFill>
+              <a:srgbClr val="E2E8F0"/>
+            </a:solidFill>
+          </a:ln>
+        </p:spPr>
+        <p:style>
+          <a:lnRef idx="1">
+            <a:schemeClr val="accent1"/>
+          </a:lnRef>
+          <a:fillRef idx="3">
+            <a:schemeClr val="accent1"/>
+          </a:fillRef>
+          <a:effectRef idx="2">
+            <a:schemeClr val="accent1"/>
+          </a:effectRef>
+          <a:fontRef idx="minor">
+            <a:schemeClr val="lt1"/>
+          </a:fontRef>
+        </p:style>
+        <p:txBody>
+          <a:bodyPr rtlCol="0" anchor="ctr" wrap="square"/>
+          <a:lstStyle/>
+          <a:p>
+            <a:pPr algn="ctr">
               <a:defRPr b="1" sz="1350">
                 <a:solidFill>
-                  <a:srgbClr val="4F46E5"/>
+                  <a:srgbClr val="0F172A"/>
                 </a:solidFill>
                 <a:latin typeface="Calibri"/>
               </a:defRPr>
             </a:pPr>
             <a:r>
-              <a:t>1. Client Presentation Tier</a:t>
-            </a:r>
-          </a:p>
-          <a:p>
+              <a:t>Multi-Tenant Core</a:t>
+            </a:r>
+          </a:p>
+          <a:p>
+            <a:br/>
             <a:pPr>
               <a:defRPr sz="1150">
                 <a:solidFill>
@@ -12601,23 +12619,74 @@
               </a:defRPr>
             </a:pPr>
             <a:r>
-              <a:t>Progressive Web App (PWA) running on HTML5, Tailwind CSS, Bootstrap 5, and Vanilla ES6+ JavaScript. Completely responsive across desktop monitors, touch POS terminals, kitchen tablets, and mobile browsers.</a:t>
-            </a:r>
-          </a:p>
-          <a:p>
-            <a:pPr>
+              <a:t>• restaurants (Tenant Master)</a:t>
+            </a:r>
+            <a:br/>
+            <a:r>
+              <a:t>• users (RBAC: Admin/Cashier/Kitchen)</a:t>
+            </a:r>
+            <a:br/>
+            <a:r>
+              <a:t>• restaurant_settings (GST, Currency)</a:t>
+            </a:r>
+          </a:p>
+        </p:txBody>
+      </p:sp>
+      <p:sp>
+        <p:nvSpPr>
+          <p:cNvPr id="9" name="Rounded Rectangle 8"/>
+          <p:cNvSpPr/>
+          <p:nvPr/>
+        </p:nvSpPr>
+        <p:spPr>
+          <a:xfrm>
+            <a:off x="4434840" y="1463040"/>
+            <a:ext cx="3291840" cy="4572000"/>
+          </a:xfrm>
+          <a:prstGeom prst="roundRect">
+            <a:avLst/>
+          </a:prstGeom>
+          <a:solidFill>
+            <a:srgbClr val="F8FAFC"/>
+          </a:solidFill>
+          <a:ln>
+            <a:solidFill>
+              <a:srgbClr val="E2E8F0"/>
+            </a:solidFill>
+          </a:ln>
+        </p:spPr>
+        <p:style>
+          <a:lnRef idx="1">
+            <a:schemeClr val="accent1"/>
+          </a:lnRef>
+          <a:fillRef idx="3">
+            <a:schemeClr val="accent1"/>
+          </a:fillRef>
+          <a:effectRef idx="2">
+            <a:schemeClr val="accent1"/>
+          </a:effectRef>
+          <a:fontRef idx="minor">
+            <a:schemeClr val="lt1"/>
+          </a:fontRef>
+        </p:style>
+        <p:txBody>
+          <a:bodyPr rtlCol="0" anchor="ctr" wrap="square"/>
+          <a:lstStyle/>
+          <a:p>
+            <a:pPr algn="ctr">
               <a:defRPr b="1" sz="1350">
                 <a:solidFill>
-                  <a:srgbClr val="4F46E5"/>
+                  <a:srgbClr val="0F172A"/>
                 </a:solidFill>
                 <a:latin typeface="Calibri"/>
               </a:defRPr>
             </a:pPr>
             <a:r>
-              <a:t>2. Application &amp; API Gateway Tier</a:t>
-            </a:r>
-          </a:p>
-          <a:p>
+              <a:t>Menu &amp; Recipe ERP</a:t>
+            </a:r>
+          </a:p>
+          <a:p>
+            <a:br/>
             <a:pPr>
               <a:defRPr sz="1150">
                 <a:solidFill>
@@ -12627,23 +12696,78 @@
               </a:defRPr>
             </a:pPr>
             <a:r>
-              <a:t>Hosted on Nginx with HTTP/2 SSL encryption. Powered by Laravel 11 MVC framework (PHP 8.3) utilizing RESTful endpoints, CSRF token security, and Role-Based Access Control (Admin, Manager, Cashier, Waiter, Kitchen).</a:t>
-            </a:r>
-          </a:p>
-          <a:p>
-            <a:pPr>
+              <a:t>• categories (Menu Hierarchy)</a:t>
+            </a:r>
+            <a:br/>
+            <a:r>
+              <a:t>• menu_items (Pricing, Veg/Non-Veg)</a:t>
+            </a:r>
+            <a:br/>
+            <a:r>
+              <a:t>• raw_materials (Inventory Stock)</a:t>
+            </a:r>
+            <a:br/>
+            <a:r>
+              <a:t>• recipes (Bill of Materials / Grams)</a:t>
+            </a:r>
+          </a:p>
+        </p:txBody>
+      </p:sp>
+      <p:sp>
+        <p:nvSpPr>
+          <p:cNvPr id="10" name="Rounded Rectangle 9"/>
+          <p:cNvSpPr/>
+          <p:nvPr/>
+        </p:nvSpPr>
+        <p:spPr>
+          <a:xfrm>
+            <a:off x="7955279" y="1463040"/>
+            <a:ext cx="3291840" cy="4572000"/>
+          </a:xfrm>
+          <a:prstGeom prst="roundRect">
+            <a:avLst/>
+          </a:prstGeom>
+          <a:solidFill>
+            <a:srgbClr val="F8FAFC"/>
+          </a:solidFill>
+          <a:ln>
+            <a:solidFill>
+              <a:srgbClr val="E2E8F0"/>
+            </a:solidFill>
+          </a:ln>
+        </p:spPr>
+        <p:style>
+          <a:lnRef idx="1">
+            <a:schemeClr val="accent1"/>
+          </a:lnRef>
+          <a:fillRef idx="3">
+            <a:schemeClr val="accent1"/>
+          </a:fillRef>
+          <a:effectRef idx="2">
+            <a:schemeClr val="accent1"/>
+          </a:effectRef>
+          <a:fontRef idx="minor">
+            <a:schemeClr val="lt1"/>
+          </a:fontRef>
+        </p:style>
+        <p:txBody>
+          <a:bodyPr rtlCol="0" anchor="ctr" wrap="square"/>
+          <a:lstStyle/>
+          <a:p>
+            <a:pPr algn="ctr">
               <a:defRPr b="1" sz="1350">
                 <a:solidFill>
-                  <a:srgbClr val="4F46E5"/>
+                  <a:srgbClr val="0F172A"/>
                 </a:solidFill>
                 <a:latin typeface="Calibri"/>
               </a:defRPr>
             </a:pPr>
             <a:r>
-              <a:t>3. Business Logic &amp; Real-Time Engine</a:t>
-            </a:r>
-          </a:p>
-          <a:p>
+              <a:t>Live Transactions</a:t>
+            </a:r>
+          </a:p>
+          <a:p>
+            <a:br/>
             <a:pPr>
               <a:defRPr sz="1150">
                 <a:solidFill>
@@ -12653,41 +12777,19 @@
               </a:defRPr>
             </a:pPr>
             <a:r>
-              <a:t>• Order Pipeline: Manages cart calculations, dynamic modifiers, discounts, and split billing.</a:t>
+              <a:t>• tables (Floor Layout &amp; Status)</a:t>
             </a:r>
             <a:br/>
             <a:r>
-              <a:t>• Inventory Depletion: Real-time recipe BOM ingredient deduction (e.g., deducting 80g cheese per pizza).</a:t>
+              <a:t>• orders (Billing, Split Payments)</a:t>
             </a:r>
             <a:br/>
             <a:r>
-              <a:t>• Gujarati Soundbox: HTML5 Web Speech API generating native audio announcements on order receipt.</a:t>
-            </a:r>
-          </a:p>
-          <a:p>
-            <a:pPr>
-              <a:defRPr b="1" sz="1350">
-                <a:solidFill>
-                  <a:srgbClr val="4F46E5"/>
-                </a:solidFill>
-                <a:latin typeface="Calibri"/>
-              </a:defRPr>
-            </a:pPr>
-            <a:r>
-              <a:t>4. Data Persistence &amp; Caching Tier</a:t>
-            </a:r>
-          </a:p>
-          <a:p>
-            <a:pPr>
-              <a:defRPr sz="1150">
-                <a:solidFill>
-                  <a:srgbClr val="1E293B"/>
-                </a:solidFill>
-                <a:latin typeface="Calibri"/>
-              </a:defRPr>
-            </a:pPr>
-            <a:r>
-              <a:t>Relational MySQL 8.0 database with indexed tenant foreign keys ensuring cryptographic data isolation between restaurants, paired with file/Redis caching for sub-50ms query responses.</a:t>
+              <a:t>• order_items (Itemized Breakdown)</a:t>
+            </a:r>
+            <a:br/>
+            <a:r>
+              <a:t>• kitchen_tickets (KDS Live Queue)</a:t>
             </a:r>
           </a:p>
         </p:txBody>
@@ -12827,7 +12929,7 @@
               </a:defRPr>
             </a:pPr>
             <a:r>
-              <a:t>Algorithm / Flowchart</a:t>
+              <a:t>System Flowchart &amp; Order Execution Pipeline</a:t>
             </a:r>
           </a:p>
         </p:txBody>

</xml_diff>

<commit_message>
docs(gtu): streamline presentation by retaining logos on title slide and maximizing content breathing space across inner slides
</commit_message>
<xml_diff>
--- a/docs/DineFlow_AI_GTU_Minor_Project_Presentation.pptx
+++ b/docs/DineFlow_AI_GTU_Minor_Project_Presentation.pptx
@@ -3786,7 +3786,7 @@
         <p:spPr>
           <a:xfrm>
             <a:off x="731520" y="320040"/>
-            <a:ext cx="7772400" cy="777240"/>
+            <a:ext cx="10698480" cy="777240"/>
           </a:xfrm>
           <a:prstGeom prst="rect">
             <a:avLst/>
@@ -3813,64 +3813,16 @@
           </a:p>
         </p:txBody>
       </p:sp>
-      <p:pic>
-        <p:nvPicPr>
-          <p:cNvPr id="5" name="Picture 4" descr="gtu_logo.png"/>
-          <p:cNvPicPr>
-            <a:picLocks noChangeAspect="1"/>
-          </p:cNvPicPr>
-          <p:nvPr/>
-        </p:nvPicPr>
-        <p:blipFill>
-          <a:blip r:embed="rId2"/>
-          <a:stretch>
-            <a:fillRect/>
-          </a:stretch>
-        </p:blipFill>
-        <p:spPr>
-          <a:xfrm>
-            <a:off x="10241280" y="182880"/>
-            <a:ext cx="731520" cy="822960"/>
-          </a:xfrm>
-          <a:prstGeom prst="rect">
-            <a:avLst/>
-          </a:prstGeom>
-        </p:spPr>
-      </p:pic>
-      <p:pic>
-        <p:nvPicPr>
-          <p:cNvPr id="6" name="Picture 5" descr="kdp_patan_logo.png"/>
-          <p:cNvPicPr>
-            <a:picLocks noChangeAspect="1"/>
-          </p:cNvPicPr>
-          <p:nvPr/>
-        </p:nvPicPr>
-        <p:blipFill>
-          <a:blip r:embed="rId3"/>
-          <a:stretch>
-            <a:fillRect/>
-          </a:stretch>
-        </p:blipFill>
-        <p:spPr>
-          <a:xfrm>
-            <a:off x="11155680" y="182880"/>
-            <a:ext cx="777240" cy="777240"/>
-          </a:xfrm>
-          <a:prstGeom prst="rect">
-            <a:avLst/>
-          </a:prstGeom>
-        </p:spPr>
-      </p:pic>
-      <p:sp>
-        <p:nvSpPr>
-          <p:cNvPr id="7" name="TextBox 6"/>
+      <p:sp>
+        <p:nvSpPr>
+          <p:cNvPr id="5" name="TextBox 4"/>
           <p:cNvSpPr txBox="1"/>
           <p:nvPr/>
         </p:nvSpPr>
         <p:spPr>
           <a:xfrm>
             <a:off x="731520" y="960120"/>
-            <a:ext cx="9144000" cy="320040"/>
+            <a:ext cx="10698480" cy="320040"/>
           </a:xfrm>
           <a:prstGeom prst="rect">
             <a:avLst/>
@@ -3899,7 +3851,7 @@
       </p:sp>
       <p:graphicFrame>
         <p:nvGraphicFramePr>
-          <p:cNvPr id="8" name="Table 7"/>
+          <p:cNvPr id="6" name="Table 5"/>
           <p:cNvGraphicFramePr>
             <a:graphicFrameLocks noGrp="1"/>
           </p:cNvGraphicFramePr>
@@ -4660,7 +4612,7 @@
       </p:graphicFrame>
       <p:sp>
         <p:nvSpPr>
-          <p:cNvPr id="9" name="TextBox 8"/>
+          <p:cNvPr id="7" name="TextBox 6"/>
           <p:cNvSpPr txBox="1"/>
           <p:nvPr/>
         </p:nvSpPr>
@@ -4807,7 +4759,7 @@
         <p:spPr>
           <a:xfrm>
             <a:off x="731520" y="320040"/>
-            <a:ext cx="7772400" cy="777240"/>
+            <a:ext cx="10698480" cy="777240"/>
           </a:xfrm>
           <a:prstGeom prst="rect">
             <a:avLst/>
@@ -4834,64 +4786,16 @@
           </a:p>
         </p:txBody>
       </p:sp>
-      <p:pic>
-        <p:nvPicPr>
-          <p:cNvPr id="5" name="Picture 4" descr="gtu_logo.png"/>
-          <p:cNvPicPr>
-            <a:picLocks noChangeAspect="1"/>
-          </p:cNvPicPr>
-          <p:nvPr/>
-        </p:nvPicPr>
-        <p:blipFill>
-          <a:blip r:embed="rId2"/>
-          <a:stretch>
-            <a:fillRect/>
-          </a:stretch>
-        </p:blipFill>
-        <p:spPr>
-          <a:xfrm>
-            <a:off x="10241280" y="182880"/>
-            <a:ext cx="731520" cy="822960"/>
-          </a:xfrm>
-          <a:prstGeom prst="rect">
-            <a:avLst/>
-          </a:prstGeom>
-        </p:spPr>
-      </p:pic>
-      <p:pic>
-        <p:nvPicPr>
-          <p:cNvPr id="6" name="Picture 5" descr="kdp_patan_logo.png"/>
-          <p:cNvPicPr>
-            <a:picLocks noChangeAspect="1"/>
-          </p:cNvPicPr>
-          <p:nvPr/>
-        </p:nvPicPr>
-        <p:blipFill>
-          <a:blip r:embed="rId3"/>
-          <a:stretch>
-            <a:fillRect/>
-          </a:stretch>
-        </p:blipFill>
-        <p:spPr>
-          <a:xfrm>
-            <a:off x="11155680" y="182880"/>
-            <a:ext cx="777240" cy="777240"/>
-          </a:xfrm>
-          <a:prstGeom prst="rect">
-            <a:avLst/>
-          </a:prstGeom>
-        </p:spPr>
-      </p:pic>
-      <p:sp>
-        <p:nvSpPr>
-          <p:cNvPr id="7" name="TextBox 6"/>
+      <p:sp>
+        <p:nvSpPr>
+          <p:cNvPr id="5" name="TextBox 4"/>
           <p:cNvSpPr txBox="1"/>
           <p:nvPr/>
         </p:nvSpPr>
         <p:spPr>
           <a:xfrm>
             <a:off x="731520" y="960120"/>
-            <a:ext cx="9144000" cy="320040"/>
+            <a:ext cx="10698480" cy="320040"/>
           </a:xfrm>
           <a:prstGeom prst="rect">
             <a:avLst/>
@@ -4920,7 +4824,7 @@
       </p:sp>
       <p:graphicFrame>
         <p:nvGraphicFramePr>
-          <p:cNvPr id="8" name="Table 7"/>
+          <p:cNvPr id="6" name="Table 5"/>
           <p:cNvGraphicFramePr>
             <a:graphicFrameLocks noGrp="1"/>
           </p:cNvGraphicFramePr>
@@ -5647,7 +5551,7 @@
         <p:spPr>
           <a:xfrm>
             <a:off x="731520" y="320040"/>
-            <a:ext cx="7772400" cy="777240"/>
+            <a:ext cx="10698480" cy="777240"/>
           </a:xfrm>
           <a:prstGeom prst="rect">
             <a:avLst/>
@@ -5674,9 +5578,45 @@
           </a:p>
         </p:txBody>
       </p:sp>
+      <p:sp>
+        <p:nvSpPr>
+          <p:cNvPr id="5" name="TextBox 4"/>
+          <p:cNvSpPr txBox="1"/>
+          <p:nvPr/>
+        </p:nvSpPr>
+        <p:spPr>
+          <a:xfrm>
+            <a:off x="731520" y="960120"/>
+            <a:ext cx="10698480" cy="320040"/>
+          </a:xfrm>
+          <a:prstGeom prst="rect">
+            <a:avLst/>
+          </a:prstGeom>
+          <a:noFill/>
+        </p:spPr>
+        <p:txBody>
+          <a:bodyPr wrap="none">
+            <a:spAutoFit/>
+          </a:bodyPr>
+          <a:lstStyle/>
+          <a:p>
+            <a:pPr>
+              <a:defRPr sz="1050" b="1">
+                <a:solidFill>
+                  <a:srgbClr val="4F46E5"/>
+                </a:solidFill>
+                <a:latin typeface="Calibri"/>
+              </a:defRPr>
+            </a:pPr>
+            <a:r>
+              <a:t>K. D. Polytechnic, Patan | Department of Computer Engineering | Minor Project (DI05000341) | Slide 12</a:t>
+            </a:r>
+          </a:p>
+        </p:txBody>
+      </p:sp>
       <p:pic>
         <p:nvPicPr>
-          <p:cNvPr id="5" name="Picture 4" descr="gtu_logo.png"/>
+          <p:cNvPr id="6" name="Picture 5" descr="retail-store.png"/>
           <p:cNvPicPr>
             <a:picLocks noChangeAspect="1"/>
           </p:cNvPicPr>
@@ -5690,17 +5630,97 @@
         </p:blipFill>
         <p:spPr>
           <a:xfrm>
-            <a:off x="10241280" y="182880"/>
-            <a:ext cx="731520" cy="822960"/>
+            <a:off x="731520" y="1371600"/>
+            <a:ext cx="3383280" cy="2286000"/>
           </a:xfrm>
           <a:prstGeom prst="rect">
             <a:avLst/>
           </a:prstGeom>
         </p:spPr>
       </p:pic>
+      <p:sp>
+        <p:nvSpPr>
+          <p:cNvPr id="7" name="Rounded Rectangle 6"/>
+          <p:cNvSpPr/>
+          <p:nvPr/>
+        </p:nvSpPr>
+        <p:spPr>
+          <a:xfrm>
+            <a:off x="731520" y="3749039"/>
+            <a:ext cx="3383280" cy="1828800"/>
+          </a:xfrm>
+          <a:prstGeom prst="roundRect">
+            <a:avLst/>
+          </a:prstGeom>
+          <a:solidFill>
+            <a:srgbClr val="F8FAFC"/>
+          </a:solidFill>
+          <a:ln>
+            <a:solidFill>
+              <a:srgbClr val="E2E8F0"/>
+            </a:solidFill>
+          </a:ln>
+        </p:spPr>
+        <p:style>
+          <a:lnRef idx="1">
+            <a:schemeClr val="accent1"/>
+          </a:lnRef>
+          <a:fillRef idx="3">
+            <a:schemeClr val="accent1"/>
+          </a:fillRef>
+          <a:effectRef idx="2">
+            <a:schemeClr val="accent1"/>
+          </a:effectRef>
+          <a:fontRef idx="minor">
+            <a:schemeClr val="lt1"/>
+          </a:fontRef>
+        </p:style>
+        <p:txBody>
+          <a:bodyPr rtlCol="0" anchor="ctr" wrap="square"/>
+          <a:lstStyle/>
+          <a:p>
+            <a:pPr algn="ctr">
+              <a:defRPr b="1" sz="1200">
+                <a:solidFill>
+                  <a:srgbClr val="4F46E5"/>
+                </a:solidFill>
+                <a:latin typeface="Calibri"/>
+              </a:defRPr>
+            </a:pPr>
+            <a:r>
+              <a:t>Figure 4(a): Web POS Terminal</a:t>
+            </a:r>
+          </a:p>
+          <a:p>
+            <a:pPr>
+              <a:defRPr sz="1050">
+                <a:solidFill>
+                  <a:srgbClr val="1E293B"/>
+                </a:solidFill>
+                <a:latin typeface="Calibri"/>
+              </a:defRPr>
+            </a:pPr>
+            <a:r>
+              <a:t>• Sub-3s checkout billing engine</a:t>
+            </a:r>
+            <a:br/>
+            <a:r>
+              <a:t>• Keyboard navigation (F1-F9)</a:t>
+            </a:r>
+            <a:br/>
+            <a:r>
+              <a:t>• Dynamic cart &amp; UPI QR billing</a:t>
+            </a:r>
+            <a:br/>
+            <a:r>
+              <a:t>• Zero local installation needed</a:t>
+            </a:r>
+          </a:p>
+        </p:txBody>
+      </p:sp>
       <p:pic>
         <p:nvPicPr>
-          <p:cNvPr id="6" name="Picture 5" descr="kdp_patan_logo.png"/>
+          <p:cNvPr id="8" name="Picture 7" descr="pos_thermal_printer.jpg"/>
           <p:cNvPicPr>
             <a:picLocks noChangeAspect="1"/>
           </p:cNvPicPr>
@@ -5714,8 +5734,8 @@
         </p:blipFill>
         <p:spPr>
           <a:xfrm>
-            <a:off x="11155680" y="182880"/>
-            <a:ext cx="777240" cy="777240"/>
+            <a:off x="4389120" y="1371600"/>
+            <a:ext cx="3383280" cy="2286000"/>
           </a:xfrm>
           <a:prstGeom prst="rect">
             <a:avLst/>
@@ -5724,43 +5744,87 @@
       </p:pic>
       <p:sp>
         <p:nvSpPr>
-          <p:cNvPr id="7" name="TextBox 6"/>
-          <p:cNvSpPr txBox="1"/>
+          <p:cNvPr id="9" name="Rounded Rectangle 8"/>
+          <p:cNvSpPr/>
           <p:nvPr/>
         </p:nvSpPr>
         <p:spPr>
           <a:xfrm>
-            <a:off x="731520" y="960120"/>
-            <a:ext cx="9144000" cy="320040"/>
-          </a:xfrm>
-          <a:prstGeom prst="rect">
+            <a:off x="4389120" y="3749039"/>
+            <a:ext cx="3383280" cy="1828800"/>
+          </a:xfrm>
+          <a:prstGeom prst="roundRect">
             <a:avLst/>
           </a:prstGeom>
-          <a:noFill/>
-        </p:spPr>
-        <p:txBody>
-          <a:bodyPr wrap="none">
-            <a:spAutoFit/>
-          </a:bodyPr>
-          <a:lstStyle/>
+          <a:solidFill>
+            <a:srgbClr val="F8FAFC"/>
+          </a:solidFill>
+          <a:ln>
+            <a:solidFill>
+              <a:srgbClr val="E2E8F0"/>
+            </a:solidFill>
+          </a:ln>
+        </p:spPr>
+        <p:style>
+          <a:lnRef idx="1">
+            <a:schemeClr val="accent1"/>
+          </a:lnRef>
+          <a:fillRef idx="3">
+            <a:schemeClr val="accent1"/>
+          </a:fillRef>
+          <a:effectRef idx="2">
+            <a:schemeClr val="accent1"/>
+          </a:effectRef>
+          <a:fontRef idx="minor">
+            <a:schemeClr val="lt1"/>
+          </a:fontRef>
+        </p:style>
+        <p:txBody>
+          <a:bodyPr rtlCol="0" anchor="ctr" wrap="square"/>
+          <a:lstStyle/>
+          <a:p>
+            <a:pPr algn="ctr">
+              <a:defRPr b="1" sz="1200">
+                <a:solidFill>
+                  <a:srgbClr val="4F46E5"/>
+                </a:solidFill>
+                <a:latin typeface="Calibri"/>
+              </a:defRPr>
+            </a:pPr>
+            <a:r>
+              <a:t>Figure 4(b): Assembled Hardware Setup</a:t>
+            </a:r>
+          </a:p>
           <a:p>
             <a:pPr>
-              <a:defRPr sz="1050" b="1">
-                <a:solidFill>
-                  <a:srgbClr val="4F46E5"/>
-                </a:solidFill>
-                <a:latin typeface="Calibri"/>
-              </a:defRPr>
-            </a:pPr>
-            <a:r>
-              <a:t>K. D. Polytechnic, Patan | Department of Computer Engineering | Minor Project (DI05000341) | Slide 12</a:t>
+              <a:defRPr sz="1050">
+                <a:solidFill>
+                  <a:srgbClr val="1E293B"/>
+                </a:solidFill>
+                <a:latin typeface="Calibri"/>
+              </a:defRPr>
+            </a:pPr>
+            <a:r>
+              <a:t>• 58mm/80mm ESC/POS printer</a:t>
+            </a:r>
+            <a:br/>
+            <a:r>
+              <a:t>• Silent raw byte-stream driver</a:t>
+            </a:r>
+            <a:br/>
+            <a:r>
+              <a:t>• Automatic guillotine cutter</a:t>
+            </a:r>
+            <a:br/>
+            <a:r>
+              <a:t>• Hardware cost under ₹2,800</a:t>
             </a:r>
           </a:p>
         </p:txBody>
       </p:sp>
       <p:pic>
         <p:nvPicPr>
-          <p:cNvPr id="8" name="Picture 7" descr="retail-store.png"/>
+          <p:cNvPr id="10" name="Picture 9" descr="about_img_1.png"/>
           <p:cNvPicPr>
             <a:picLocks noChangeAspect="1"/>
           </p:cNvPicPr>
@@ -5774,7 +5838,7 @@
         </p:blipFill>
         <p:spPr>
           <a:xfrm>
-            <a:off x="731520" y="1371600"/>
+            <a:off x="8046720" y="1371600"/>
             <a:ext cx="3383280" cy="2286000"/>
           </a:xfrm>
           <a:prstGeom prst="rect">
@@ -5784,13 +5848,13 @@
       </p:pic>
       <p:sp>
         <p:nvSpPr>
-          <p:cNvPr id="9" name="Rounded Rectangle 8"/>
+          <p:cNvPr id="11" name="Rounded Rectangle 10"/>
           <p:cNvSpPr/>
           <p:nvPr/>
         </p:nvSpPr>
         <p:spPr>
           <a:xfrm>
-            <a:off x="731520" y="3749039"/>
+            <a:off x="8046720" y="3749039"/>
             <a:ext cx="3383280" cy="1828800"/>
           </a:xfrm>
           <a:prstGeom prst="roundRect">
@@ -5832,7 +5896,7 @@
               </a:defRPr>
             </a:pPr>
             <a:r>
-              <a:t>Figure 4(a): Web POS Terminal</a:t>
+              <a:t>Figure 4(c): Cloud Management ERP</a:t>
             </a:r>
           </a:p>
           <a:p>
@@ -5845,226 +5909,18 @@
               </a:defRPr>
             </a:pPr>
             <a:r>
-              <a:t>• Sub-3s checkout billing engine</a:t>
+              <a:t>• BCG AI menu engineering matrix</a:t>
             </a:r>
             <a:br/>
             <a:r>
-              <a:t>• Keyboard navigation (F1-F9)</a:t>
+              <a:t>• Raw recipe auto-depletion engine</a:t>
             </a:r>
             <a:br/>
             <a:r>
-              <a:t>• Dynamic cart &amp; UPI QR billing</a:t>
+              <a:t>• Sub-180ms live kitchen KDS</a:t>
             </a:r>
             <a:br/>
             <a:r>
-              <a:t>• Zero local installation needed</a:t>
-            </a:r>
-          </a:p>
-        </p:txBody>
-      </p:sp>
-      <p:pic>
-        <p:nvPicPr>
-          <p:cNvPr id="10" name="Picture 9" descr="pos_thermal_printer.jpg"/>
-          <p:cNvPicPr>
-            <a:picLocks noChangeAspect="1"/>
-          </p:cNvPicPr>
-          <p:nvPr/>
-        </p:nvPicPr>
-        <p:blipFill>
-          <a:blip r:embed="rId5"/>
-          <a:stretch>
-            <a:fillRect/>
-          </a:stretch>
-        </p:blipFill>
-        <p:spPr>
-          <a:xfrm>
-            <a:off x="4389120" y="1371600"/>
-            <a:ext cx="3383280" cy="2286000"/>
-          </a:xfrm>
-          <a:prstGeom prst="rect">
-            <a:avLst/>
-          </a:prstGeom>
-        </p:spPr>
-      </p:pic>
-      <p:sp>
-        <p:nvSpPr>
-          <p:cNvPr id="11" name="Rounded Rectangle 10"/>
-          <p:cNvSpPr/>
-          <p:nvPr/>
-        </p:nvSpPr>
-        <p:spPr>
-          <a:xfrm>
-            <a:off x="4389120" y="3749039"/>
-            <a:ext cx="3383280" cy="1828800"/>
-          </a:xfrm>
-          <a:prstGeom prst="roundRect">
-            <a:avLst/>
-          </a:prstGeom>
-          <a:solidFill>
-            <a:srgbClr val="F8FAFC"/>
-          </a:solidFill>
-          <a:ln>
-            <a:solidFill>
-              <a:srgbClr val="E2E8F0"/>
-            </a:solidFill>
-          </a:ln>
-        </p:spPr>
-        <p:style>
-          <a:lnRef idx="1">
-            <a:schemeClr val="accent1"/>
-          </a:lnRef>
-          <a:fillRef idx="3">
-            <a:schemeClr val="accent1"/>
-          </a:fillRef>
-          <a:effectRef idx="2">
-            <a:schemeClr val="accent1"/>
-          </a:effectRef>
-          <a:fontRef idx="minor">
-            <a:schemeClr val="lt1"/>
-          </a:fontRef>
-        </p:style>
-        <p:txBody>
-          <a:bodyPr rtlCol="0" anchor="ctr" wrap="square"/>
-          <a:lstStyle/>
-          <a:p>
-            <a:pPr algn="ctr">
-              <a:defRPr b="1" sz="1200">
-                <a:solidFill>
-                  <a:srgbClr val="4F46E5"/>
-                </a:solidFill>
-                <a:latin typeface="Calibri"/>
-              </a:defRPr>
-            </a:pPr>
-            <a:r>
-              <a:t>Figure 4(b): Assembled Hardware Setup</a:t>
-            </a:r>
-          </a:p>
-          <a:p>
-            <a:pPr>
-              <a:defRPr sz="1050">
-                <a:solidFill>
-                  <a:srgbClr val="1E293B"/>
-                </a:solidFill>
-                <a:latin typeface="Calibri"/>
-              </a:defRPr>
-            </a:pPr>
-            <a:r>
-              <a:t>• 58mm/80mm ESC/POS printer</a:t>
-            </a:r>
-            <a:br/>
-            <a:r>
-              <a:t>• Silent raw byte-stream driver</a:t>
-            </a:r>
-            <a:br/>
-            <a:r>
-              <a:t>• Automatic guillotine cutter</a:t>
-            </a:r>
-            <a:br/>
-            <a:r>
-              <a:t>• Hardware cost under ₹2,800</a:t>
-            </a:r>
-          </a:p>
-        </p:txBody>
-      </p:sp>
-      <p:pic>
-        <p:nvPicPr>
-          <p:cNvPr id="12" name="Picture 11" descr="about_img_1.png"/>
-          <p:cNvPicPr>
-            <a:picLocks noChangeAspect="1"/>
-          </p:cNvPicPr>
-          <p:nvPr/>
-        </p:nvPicPr>
-        <p:blipFill>
-          <a:blip r:embed="rId6"/>
-          <a:stretch>
-            <a:fillRect/>
-          </a:stretch>
-        </p:blipFill>
-        <p:spPr>
-          <a:xfrm>
-            <a:off x="8046720" y="1371600"/>
-            <a:ext cx="3383280" cy="2286000"/>
-          </a:xfrm>
-          <a:prstGeom prst="rect">
-            <a:avLst/>
-          </a:prstGeom>
-        </p:spPr>
-      </p:pic>
-      <p:sp>
-        <p:nvSpPr>
-          <p:cNvPr id="13" name="Rounded Rectangle 12"/>
-          <p:cNvSpPr/>
-          <p:nvPr/>
-        </p:nvSpPr>
-        <p:spPr>
-          <a:xfrm>
-            <a:off x="8046720" y="3749039"/>
-            <a:ext cx="3383280" cy="1828800"/>
-          </a:xfrm>
-          <a:prstGeom prst="roundRect">
-            <a:avLst/>
-          </a:prstGeom>
-          <a:solidFill>
-            <a:srgbClr val="F8FAFC"/>
-          </a:solidFill>
-          <a:ln>
-            <a:solidFill>
-              <a:srgbClr val="E2E8F0"/>
-            </a:solidFill>
-          </a:ln>
-        </p:spPr>
-        <p:style>
-          <a:lnRef idx="1">
-            <a:schemeClr val="accent1"/>
-          </a:lnRef>
-          <a:fillRef idx="3">
-            <a:schemeClr val="accent1"/>
-          </a:fillRef>
-          <a:effectRef idx="2">
-            <a:schemeClr val="accent1"/>
-          </a:effectRef>
-          <a:fontRef idx="minor">
-            <a:schemeClr val="lt1"/>
-          </a:fontRef>
-        </p:style>
-        <p:txBody>
-          <a:bodyPr rtlCol="0" anchor="ctr" wrap="square"/>
-          <a:lstStyle/>
-          <a:p>
-            <a:pPr algn="ctr">
-              <a:defRPr b="1" sz="1200">
-                <a:solidFill>
-                  <a:srgbClr val="4F46E5"/>
-                </a:solidFill>
-                <a:latin typeface="Calibri"/>
-              </a:defRPr>
-            </a:pPr>
-            <a:r>
-              <a:t>Figure 4(c): Cloud Management ERP</a:t>
-            </a:r>
-          </a:p>
-          <a:p>
-            <a:pPr>
-              <a:defRPr sz="1050">
-                <a:solidFill>
-                  <a:srgbClr val="1E293B"/>
-                </a:solidFill>
-                <a:latin typeface="Calibri"/>
-              </a:defRPr>
-            </a:pPr>
-            <a:r>
-              <a:t>• BCG AI menu engineering matrix</a:t>
-            </a:r>
-            <a:br/>
-            <a:r>
-              <a:t>• Raw recipe auto-depletion engine</a:t>
-            </a:r>
-            <a:br/>
-            <a:r>
-              <a:t>• Sub-180ms live kitchen KDS</a:t>
-            </a:r>
-            <a:br/>
-            <a:r>
               <a:t>• Gujarati audio alert soundbox</a:t>
             </a:r>
           </a:p>
@@ -6072,7 +5928,7 @@
       </p:sp>
       <p:sp>
         <p:nvSpPr>
-          <p:cNvPr id="14" name="Rounded Rectangle 13"/>
+          <p:cNvPr id="12" name="Rounded Rectangle 11"/>
           <p:cNvSpPr/>
           <p:nvPr/>
         </p:nvSpPr>
@@ -6238,7 +6094,7 @@
         <p:spPr>
           <a:xfrm>
             <a:off x="731520" y="320040"/>
-            <a:ext cx="7772400" cy="777240"/>
+            <a:ext cx="10698480" cy="777240"/>
           </a:xfrm>
           <a:prstGeom prst="rect">
             <a:avLst/>
@@ -6265,64 +6121,16 @@
           </a:p>
         </p:txBody>
       </p:sp>
-      <p:pic>
-        <p:nvPicPr>
-          <p:cNvPr id="5" name="Picture 4" descr="gtu_logo.png"/>
-          <p:cNvPicPr>
-            <a:picLocks noChangeAspect="1"/>
-          </p:cNvPicPr>
-          <p:nvPr/>
-        </p:nvPicPr>
-        <p:blipFill>
-          <a:blip r:embed="rId2"/>
-          <a:stretch>
-            <a:fillRect/>
-          </a:stretch>
-        </p:blipFill>
-        <p:spPr>
-          <a:xfrm>
-            <a:off x="10241280" y="182880"/>
-            <a:ext cx="731520" cy="822960"/>
-          </a:xfrm>
-          <a:prstGeom prst="rect">
-            <a:avLst/>
-          </a:prstGeom>
-        </p:spPr>
-      </p:pic>
-      <p:pic>
-        <p:nvPicPr>
-          <p:cNvPr id="6" name="Picture 5" descr="kdp_patan_logo.png"/>
-          <p:cNvPicPr>
-            <a:picLocks noChangeAspect="1"/>
-          </p:cNvPicPr>
-          <p:nvPr/>
-        </p:nvPicPr>
-        <p:blipFill>
-          <a:blip r:embed="rId3"/>
-          <a:stretch>
-            <a:fillRect/>
-          </a:stretch>
-        </p:blipFill>
-        <p:spPr>
-          <a:xfrm>
-            <a:off x="11155680" y="182880"/>
-            <a:ext cx="777240" cy="777240"/>
-          </a:xfrm>
-          <a:prstGeom prst="rect">
-            <a:avLst/>
-          </a:prstGeom>
-        </p:spPr>
-      </p:pic>
-      <p:sp>
-        <p:nvSpPr>
-          <p:cNvPr id="7" name="TextBox 6"/>
+      <p:sp>
+        <p:nvSpPr>
+          <p:cNvPr id="5" name="TextBox 4"/>
           <p:cNvSpPr txBox="1"/>
           <p:nvPr/>
         </p:nvSpPr>
         <p:spPr>
           <a:xfrm>
             <a:off x="731520" y="960120"/>
-            <a:ext cx="9144000" cy="320040"/>
+            <a:ext cx="10698480" cy="320040"/>
           </a:xfrm>
           <a:prstGeom prst="rect">
             <a:avLst/>
@@ -6351,7 +6159,7 @@
       </p:sp>
       <p:sp>
         <p:nvSpPr>
-          <p:cNvPr id="8" name="Rounded Rectangle 7"/>
+          <p:cNvPr id="6" name="Rounded Rectangle 5"/>
           <p:cNvSpPr/>
           <p:nvPr/>
         </p:nvSpPr>
@@ -6432,7 +6240,7 @@
       </p:sp>
       <p:sp>
         <p:nvSpPr>
-          <p:cNvPr id="9" name="Rounded Rectangle 8"/>
+          <p:cNvPr id="7" name="Rounded Rectangle 6"/>
           <p:cNvSpPr/>
           <p:nvPr/>
         </p:nvSpPr>
@@ -6513,7 +6321,7 @@
       </p:sp>
       <p:sp>
         <p:nvSpPr>
-          <p:cNvPr id="10" name="Rounded Rectangle 9"/>
+          <p:cNvPr id="8" name="Rounded Rectangle 7"/>
           <p:cNvSpPr/>
           <p:nvPr/>
         </p:nvSpPr>
@@ -6594,7 +6402,7 @@
       </p:sp>
       <p:sp>
         <p:nvSpPr>
-          <p:cNvPr id="11" name="Rounded Rectangle 10"/>
+          <p:cNvPr id="9" name="Rounded Rectangle 8"/>
           <p:cNvSpPr/>
           <p:nvPr/>
         </p:nvSpPr>
@@ -6675,7 +6483,7 @@
       </p:sp>
       <p:sp>
         <p:nvSpPr>
-          <p:cNvPr id="12" name="Rounded Rectangle 11"/>
+          <p:cNvPr id="10" name="Rounded Rectangle 9"/>
           <p:cNvSpPr/>
           <p:nvPr/>
         </p:nvSpPr>
@@ -6921,7 +6729,7 @@
         <p:spPr>
           <a:xfrm>
             <a:off x="731520" y="320040"/>
-            <a:ext cx="7772400" cy="777240"/>
+            <a:ext cx="10698480" cy="777240"/>
           </a:xfrm>
           <a:prstGeom prst="rect">
             <a:avLst/>
@@ -6948,64 +6756,16 @@
           </a:p>
         </p:txBody>
       </p:sp>
-      <p:pic>
-        <p:nvPicPr>
-          <p:cNvPr id="5" name="Picture 4" descr="gtu_logo.png"/>
-          <p:cNvPicPr>
-            <a:picLocks noChangeAspect="1"/>
-          </p:cNvPicPr>
-          <p:nvPr/>
-        </p:nvPicPr>
-        <p:blipFill>
-          <a:blip r:embed="rId2"/>
-          <a:stretch>
-            <a:fillRect/>
-          </a:stretch>
-        </p:blipFill>
-        <p:spPr>
-          <a:xfrm>
-            <a:off x="10241280" y="182880"/>
-            <a:ext cx="731520" cy="822960"/>
-          </a:xfrm>
-          <a:prstGeom prst="rect">
-            <a:avLst/>
-          </a:prstGeom>
-        </p:spPr>
-      </p:pic>
-      <p:pic>
-        <p:nvPicPr>
-          <p:cNvPr id="6" name="Picture 5" descr="kdp_patan_logo.png"/>
-          <p:cNvPicPr>
-            <a:picLocks noChangeAspect="1"/>
-          </p:cNvPicPr>
-          <p:nvPr/>
-        </p:nvPicPr>
-        <p:blipFill>
-          <a:blip r:embed="rId3"/>
-          <a:stretch>
-            <a:fillRect/>
-          </a:stretch>
-        </p:blipFill>
-        <p:spPr>
-          <a:xfrm>
-            <a:off x="11155680" y="182880"/>
-            <a:ext cx="777240" cy="777240"/>
-          </a:xfrm>
-          <a:prstGeom prst="rect">
-            <a:avLst/>
-          </a:prstGeom>
-        </p:spPr>
-      </p:pic>
-      <p:sp>
-        <p:nvSpPr>
-          <p:cNvPr id="7" name="TextBox 6"/>
+      <p:sp>
+        <p:nvSpPr>
+          <p:cNvPr id="5" name="TextBox 4"/>
           <p:cNvSpPr txBox="1"/>
           <p:nvPr/>
         </p:nvSpPr>
         <p:spPr>
           <a:xfrm>
             <a:off x="731520" y="960120"/>
-            <a:ext cx="9144000" cy="320040"/>
+            <a:ext cx="10698480" cy="320040"/>
           </a:xfrm>
           <a:prstGeom prst="rect">
             <a:avLst/>
@@ -7034,7 +6794,7 @@
       </p:sp>
       <p:graphicFrame>
         <p:nvGraphicFramePr>
-          <p:cNvPr id="8" name="Table 7"/>
+          <p:cNvPr id="6" name="Table 5"/>
           <p:cNvGraphicFramePr>
             <a:graphicFrameLocks noGrp="1"/>
           </p:cNvGraphicFramePr>
@@ -7565,7 +7325,7 @@
         <p:spPr>
           <a:xfrm>
             <a:off x="731520" y="320040"/>
-            <a:ext cx="7772400" cy="777240"/>
+            <a:ext cx="10698480" cy="777240"/>
           </a:xfrm>
           <a:prstGeom prst="rect">
             <a:avLst/>
@@ -7592,64 +7352,16 @@
           </a:p>
         </p:txBody>
       </p:sp>
-      <p:pic>
-        <p:nvPicPr>
-          <p:cNvPr id="5" name="Picture 4" descr="gtu_logo.png"/>
-          <p:cNvPicPr>
-            <a:picLocks noChangeAspect="1"/>
-          </p:cNvPicPr>
-          <p:nvPr/>
-        </p:nvPicPr>
-        <p:blipFill>
-          <a:blip r:embed="rId2"/>
-          <a:stretch>
-            <a:fillRect/>
-          </a:stretch>
-        </p:blipFill>
-        <p:spPr>
-          <a:xfrm>
-            <a:off x="10241280" y="182880"/>
-            <a:ext cx="731520" cy="822960"/>
-          </a:xfrm>
-          <a:prstGeom prst="rect">
-            <a:avLst/>
-          </a:prstGeom>
-        </p:spPr>
-      </p:pic>
-      <p:pic>
-        <p:nvPicPr>
-          <p:cNvPr id="6" name="Picture 5" descr="kdp_patan_logo.png"/>
-          <p:cNvPicPr>
-            <a:picLocks noChangeAspect="1"/>
-          </p:cNvPicPr>
-          <p:nvPr/>
-        </p:nvPicPr>
-        <p:blipFill>
-          <a:blip r:embed="rId3"/>
-          <a:stretch>
-            <a:fillRect/>
-          </a:stretch>
-        </p:blipFill>
-        <p:spPr>
-          <a:xfrm>
-            <a:off x="11155680" y="182880"/>
-            <a:ext cx="777240" cy="777240"/>
-          </a:xfrm>
-          <a:prstGeom prst="rect">
-            <a:avLst/>
-          </a:prstGeom>
-        </p:spPr>
-      </p:pic>
-      <p:sp>
-        <p:nvSpPr>
-          <p:cNvPr id="7" name="TextBox 6"/>
+      <p:sp>
+        <p:nvSpPr>
+          <p:cNvPr id="5" name="TextBox 4"/>
           <p:cNvSpPr txBox="1"/>
           <p:nvPr/>
         </p:nvSpPr>
         <p:spPr>
           <a:xfrm>
             <a:off x="731520" y="960120"/>
-            <a:ext cx="9144000" cy="320040"/>
+            <a:ext cx="10698480" cy="320040"/>
           </a:xfrm>
           <a:prstGeom prst="rect">
             <a:avLst/>
@@ -7678,7 +7390,7 @@
       </p:sp>
       <p:sp>
         <p:nvSpPr>
-          <p:cNvPr id="8" name="Rounded Rectangle 7"/>
+          <p:cNvPr id="6" name="Rounded Rectangle 5"/>
           <p:cNvSpPr/>
           <p:nvPr/>
         </p:nvSpPr>
@@ -7813,7 +7525,7 @@
       </p:sp>
       <p:sp>
         <p:nvSpPr>
-          <p:cNvPr id="9" name="Rounded Rectangle 8"/>
+          <p:cNvPr id="7" name="Rounded Rectangle 6"/>
           <p:cNvSpPr/>
           <p:nvPr/>
         </p:nvSpPr>
@@ -8059,7 +7771,7 @@
         <p:spPr>
           <a:xfrm>
             <a:off x="731520" y="320040"/>
-            <a:ext cx="7772400" cy="777240"/>
+            <a:ext cx="10698480" cy="777240"/>
           </a:xfrm>
           <a:prstGeom prst="rect">
             <a:avLst/>
@@ -8086,64 +7798,16 @@
           </a:p>
         </p:txBody>
       </p:sp>
-      <p:pic>
-        <p:nvPicPr>
-          <p:cNvPr id="5" name="Picture 4" descr="gtu_logo.png"/>
-          <p:cNvPicPr>
-            <a:picLocks noChangeAspect="1"/>
-          </p:cNvPicPr>
-          <p:nvPr/>
-        </p:nvPicPr>
-        <p:blipFill>
-          <a:blip r:embed="rId2"/>
-          <a:stretch>
-            <a:fillRect/>
-          </a:stretch>
-        </p:blipFill>
-        <p:spPr>
-          <a:xfrm>
-            <a:off x="10241280" y="182880"/>
-            <a:ext cx="731520" cy="822960"/>
-          </a:xfrm>
-          <a:prstGeom prst="rect">
-            <a:avLst/>
-          </a:prstGeom>
-        </p:spPr>
-      </p:pic>
-      <p:pic>
-        <p:nvPicPr>
-          <p:cNvPr id="6" name="Picture 5" descr="kdp_patan_logo.png"/>
-          <p:cNvPicPr>
-            <a:picLocks noChangeAspect="1"/>
-          </p:cNvPicPr>
-          <p:nvPr/>
-        </p:nvPicPr>
-        <p:blipFill>
-          <a:blip r:embed="rId3"/>
-          <a:stretch>
-            <a:fillRect/>
-          </a:stretch>
-        </p:blipFill>
-        <p:spPr>
-          <a:xfrm>
-            <a:off x="11155680" y="182880"/>
-            <a:ext cx="777240" cy="777240"/>
-          </a:xfrm>
-          <a:prstGeom prst="rect">
-            <a:avLst/>
-          </a:prstGeom>
-        </p:spPr>
-      </p:pic>
-      <p:sp>
-        <p:nvSpPr>
-          <p:cNvPr id="7" name="TextBox 6"/>
+      <p:sp>
+        <p:nvSpPr>
+          <p:cNvPr id="5" name="TextBox 4"/>
           <p:cNvSpPr txBox="1"/>
           <p:nvPr/>
         </p:nvSpPr>
         <p:spPr>
           <a:xfrm>
             <a:off x="731520" y="960120"/>
-            <a:ext cx="9144000" cy="320040"/>
+            <a:ext cx="10698480" cy="320040"/>
           </a:xfrm>
           <a:prstGeom prst="rect">
             <a:avLst/>
@@ -8172,7 +7836,7 @@
       </p:sp>
       <p:sp>
         <p:nvSpPr>
-          <p:cNvPr id="8" name="Rounded Rectangle 7"/>
+          <p:cNvPr id="6" name="Rounded Rectangle 5"/>
           <p:cNvSpPr/>
           <p:nvPr/>
         </p:nvSpPr>
@@ -8266,7 +7930,7 @@
       </p:sp>
       <p:sp>
         <p:nvSpPr>
-          <p:cNvPr id="9" name="Rounded Rectangle 8"/>
+          <p:cNvPr id="7" name="Rounded Rectangle 6"/>
           <p:cNvSpPr/>
           <p:nvPr/>
         </p:nvSpPr>
@@ -8360,7 +8024,7 @@
       </p:sp>
       <p:sp>
         <p:nvSpPr>
-          <p:cNvPr id="10" name="Rounded Rectangle 9"/>
+          <p:cNvPr id="8" name="Rounded Rectangle 7"/>
           <p:cNvSpPr/>
           <p:nvPr/>
         </p:nvSpPr>
@@ -8561,7 +8225,7 @@
         <p:spPr>
           <a:xfrm>
             <a:off x="731520" y="320040"/>
-            <a:ext cx="7772400" cy="777240"/>
+            <a:ext cx="10698480" cy="777240"/>
           </a:xfrm>
           <a:prstGeom prst="rect">
             <a:avLst/>
@@ -8588,64 +8252,16 @@
           </a:p>
         </p:txBody>
       </p:sp>
-      <p:pic>
-        <p:nvPicPr>
-          <p:cNvPr id="5" name="Picture 4" descr="gtu_logo.png"/>
-          <p:cNvPicPr>
-            <a:picLocks noChangeAspect="1"/>
-          </p:cNvPicPr>
-          <p:nvPr/>
-        </p:nvPicPr>
-        <p:blipFill>
-          <a:blip r:embed="rId2"/>
-          <a:stretch>
-            <a:fillRect/>
-          </a:stretch>
-        </p:blipFill>
-        <p:spPr>
-          <a:xfrm>
-            <a:off x="10241280" y="182880"/>
-            <a:ext cx="731520" cy="822960"/>
-          </a:xfrm>
-          <a:prstGeom prst="rect">
-            <a:avLst/>
-          </a:prstGeom>
-        </p:spPr>
-      </p:pic>
-      <p:pic>
-        <p:nvPicPr>
-          <p:cNvPr id="6" name="Picture 5" descr="kdp_patan_logo.png"/>
-          <p:cNvPicPr>
-            <a:picLocks noChangeAspect="1"/>
-          </p:cNvPicPr>
-          <p:nvPr/>
-        </p:nvPicPr>
-        <p:blipFill>
-          <a:blip r:embed="rId3"/>
-          <a:stretch>
-            <a:fillRect/>
-          </a:stretch>
-        </p:blipFill>
-        <p:spPr>
-          <a:xfrm>
-            <a:off x="11155680" y="182880"/>
-            <a:ext cx="777240" cy="777240"/>
-          </a:xfrm>
-          <a:prstGeom prst="rect">
-            <a:avLst/>
-          </a:prstGeom>
-        </p:spPr>
-      </p:pic>
-      <p:sp>
-        <p:nvSpPr>
-          <p:cNvPr id="7" name="TextBox 6"/>
+      <p:sp>
+        <p:nvSpPr>
+          <p:cNvPr id="5" name="TextBox 4"/>
           <p:cNvSpPr txBox="1"/>
           <p:nvPr/>
         </p:nvSpPr>
         <p:spPr>
           <a:xfrm>
             <a:off x="731520" y="960120"/>
-            <a:ext cx="9144000" cy="320040"/>
+            <a:ext cx="10698480" cy="320040"/>
           </a:xfrm>
           <a:prstGeom prst="rect">
             <a:avLst/>
@@ -8674,7 +8290,7 @@
       </p:sp>
       <p:sp>
         <p:nvSpPr>
-          <p:cNvPr id="8" name="Rounded Rectangle 7"/>
+          <p:cNvPr id="6" name="Rounded Rectangle 5"/>
           <p:cNvSpPr/>
           <p:nvPr/>
         </p:nvSpPr>
@@ -8959,7 +8575,7 @@
         <p:spPr>
           <a:xfrm>
             <a:off x="731520" y="320040"/>
-            <a:ext cx="7772400" cy="777240"/>
+            <a:ext cx="10698480" cy="777240"/>
           </a:xfrm>
           <a:prstGeom prst="rect">
             <a:avLst/>
@@ -8986,64 +8602,16 @@
           </a:p>
         </p:txBody>
       </p:sp>
-      <p:pic>
-        <p:nvPicPr>
-          <p:cNvPr id="5" name="Picture 4" descr="gtu_logo.png"/>
-          <p:cNvPicPr>
-            <a:picLocks noChangeAspect="1"/>
-          </p:cNvPicPr>
-          <p:nvPr/>
-        </p:nvPicPr>
-        <p:blipFill>
-          <a:blip r:embed="rId2"/>
-          <a:stretch>
-            <a:fillRect/>
-          </a:stretch>
-        </p:blipFill>
-        <p:spPr>
-          <a:xfrm>
-            <a:off x="10241280" y="182880"/>
-            <a:ext cx="731520" cy="822960"/>
-          </a:xfrm>
-          <a:prstGeom prst="rect">
-            <a:avLst/>
-          </a:prstGeom>
-        </p:spPr>
-      </p:pic>
-      <p:pic>
-        <p:nvPicPr>
-          <p:cNvPr id="6" name="Picture 5" descr="kdp_patan_logo.png"/>
-          <p:cNvPicPr>
-            <a:picLocks noChangeAspect="1"/>
-          </p:cNvPicPr>
-          <p:nvPr/>
-        </p:nvPicPr>
-        <p:blipFill>
-          <a:blip r:embed="rId3"/>
-          <a:stretch>
-            <a:fillRect/>
-          </a:stretch>
-        </p:blipFill>
-        <p:spPr>
-          <a:xfrm>
-            <a:off x="11155680" y="182880"/>
-            <a:ext cx="777240" cy="777240"/>
-          </a:xfrm>
-          <a:prstGeom prst="rect">
-            <a:avLst/>
-          </a:prstGeom>
-        </p:spPr>
-      </p:pic>
-      <p:sp>
-        <p:nvSpPr>
-          <p:cNvPr id="7" name="TextBox 6"/>
+      <p:sp>
+        <p:nvSpPr>
+          <p:cNvPr id="5" name="TextBox 4"/>
           <p:cNvSpPr txBox="1"/>
           <p:nvPr/>
         </p:nvSpPr>
         <p:spPr>
           <a:xfrm>
             <a:off x="731520" y="960120"/>
-            <a:ext cx="9144000" cy="320040"/>
+            <a:ext cx="10698480" cy="320040"/>
           </a:xfrm>
           <a:prstGeom prst="rect">
             <a:avLst/>
@@ -9072,7 +8640,7 @@
       </p:sp>
       <p:sp>
         <p:nvSpPr>
-          <p:cNvPr id="8" name="TextBox 7"/>
+          <p:cNvPr id="6" name="TextBox 5"/>
           <p:cNvSpPr txBox="1"/>
           <p:nvPr/>
         </p:nvSpPr>
@@ -9389,7 +8957,7 @@
         <p:spPr>
           <a:xfrm>
             <a:off x="731520" y="320040"/>
-            <a:ext cx="7772400" cy="777240"/>
+            <a:ext cx="10698480" cy="777240"/>
           </a:xfrm>
           <a:prstGeom prst="rect">
             <a:avLst/>
@@ -9416,64 +8984,16 @@
           </a:p>
         </p:txBody>
       </p:sp>
-      <p:pic>
-        <p:nvPicPr>
-          <p:cNvPr id="5" name="Picture 4" descr="gtu_logo.png"/>
-          <p:cNvPicPr>
-            <a:picLocks noChangeAspect="1"/>
-          </p:cNvPicPr>
-          <p:nvPr/>
-        </p:nvPicPr>
-        <p:blipFill>
-          <a:blip r:embed="rId2"/>
-          <a:stretch>
-            <a:fillRect/>
-          </a:stretch>
-        </p:blipFill>
-        <p:spPr>
-          <a:xfrm>
-            <a:off x="10241280" y="182880"/>
-            <a:ext cx="731520" cy="822960"/>
-          </a:xfrm>
-          <a:prstGeom prst="rect">
-            <a:avLst/>
-          </a:prstGeom>
-        </p:spPr>
-      </p:pic>
-      <p:pic>
-        <p:nvPicPr>
-          <p:cNvPr id="6" name="Picture 5" descr="kdp_patan_logo.png"/>
-          <p:cNvPicPr>
-            <a:picLocks noChangeAspect="1"/>
-          </p:cNvPicPr>
-          <p:nvPr/>
-        </p:nvPicPr>
-        <p:blipFill>
-          <a:blip r:embed="rId3"/>
-          <a:stretch>
-            <a:fillRect/>
-          </a:stretch>
-        </p:blipFill>
-        <p:spPr>
-          <a:xfrm>
-            <a:off x="11155680" y="182880"/>
-            <a:ext cx="777240" cy="777240"/>
-          </a:xfrm>
-          <a:prstGeom prst="rect">
-            <a:avLst/>
-          </a:prstGeom>
-        </p:spPr>
-      </p:pic>
-      <p:sp>
-        <p:nvSpPr>
-          <p:cNvPr id="7" name="TextBox 6"/>
+      <p:sp>
+        <p:nvSpPr>
+          <p:cNvPr id="5" name="TextBox 4"/>
           <p:cNvSpPr txBox="1"/>
           <p:nvPr/>
         </p:nvSpPr>
         <p:spPr>
           <a:xfrm>
             <a:off x="731520" y="960120"/>
-            <a:ext cx="9144000" cy="320040"/>
+            <a:ext cx="10698480" cy="320040"/>
           </a:xfrm>
           <a:prstGeom prst="rect">
             <a:avLst/>
@@ -9502,7 +9022,7 @@
       </p:sp>
       <p:sp>
         <p:nvSpPr>
-          <p:cNvPr id="8" name="Rounded Rectangle 7"/>
+          <p:cNvPr id="6" name="Rounded Rectangle 5"/>
           <p:cNvSpPr/>
           <p:nvPr/>
         </p:nvSpPr>
@@ -9630,7 +9150,7 @@
       </p:sp>
       <p:sp>
         <p:nvSpPr>
-          <p:cNvPr id="9" name="Rounded Rectangle 8"/>
+          <p:cNvPr id="7" name="Rounded Rectangle 6"/>
           <p:cNvSpPr/>
           <p:nvPr/>
         </p:nvSpPr>
@@ -9824,7 +9344,7 @@
         <p:spPr>
           <a:xfrm>
             <a:off x="731520" y="320040"/>
-            <a:ext cx="7772400" cy="777240"/>
+            <a:ext cx="10698480" cy="777240"/>
           </a:xfrm>
           <a:prstGeom prst="rect">
             <a:avLst/>
@@ -9851,64 +9371,16 @@
           </a:p>
         </p:txBody>
       </p:sp>
-      <p:pic>
-        <p:nvPicPr>
-          <p:cNvPr id="5" name="Picture 4" descr="gtu_logo.png"/>
-          <p:cNvPicPr>
-            <a:picLocks noChangeAspect="1"/>
-          </p:cNvPicPr>
-          <p:nvPr/>
-        </p:nvPicPr>
-        <p:blipFill>
-          <a:blip r:embed="rId2"/>
-          <a:stretch>
-            <a:fillRect/>
-          </a:stretch>
-        </p:blipFill>
-        <p:spPr>
-          <a:xfrm>
-            <a:off x="10241280" y="182880"/>
-            <a:ext cx="731520" cy="822960"/>
-          </a:xfrm>
-          <a:prstGeom prst="rect">
-            <a:avLst/>
-          </a:prstGeom>
-        </p:spPr>
-      </p:pic>
-      <p:pic>
-        <p:nvPicPr>
-          <p:cNvPr id="6" name="Picture 5" descr="kdp_patan_logo.png"/>
-          <p:cNvPicPr>
-            <a:picLocks noChangeAspect="1"/>
-          </p:cNvPicPr>
-          <p:nvPr/>
-        </p:nvPicPr>
-        <p:blipFill>
-          <a:blip r:embed="rId3"/>
-          <a:stretch>
-            <a:fillRect/>
-          </a:stretch>
-        </p:blipFill>
-        <p:spPr>
-          <a:xfrm>
-            <a:off x="11155680" y="182880"/>
-            <a:ext cx="777240" cy="777240"/>
-          </a:xfrm>
-          <a:prstGeom prst="rect">
-            <a:avLst/>
-          </a:prstGeom>
-        </p:spPr>
-      </p:pic>
-      <p:sp>
-        <p:nvSpPr>
-          <p:cNvPr id="7" name="TextBox 6"/>
+      <p:sp>
+        <p:nvSpPr>
+          <p:cNvPr id="5" name="TextBox 4"/>
           <p:cNvSpPr txBox="1"/>
           <p:nvPr/>
         </p:nvSpPr>
         <p:spPr>
           <a:xfrm>
             <a:off x="731520" y="960120"/>
-            <a:ext cx="9144000" cy="320040"/>
+            <a:ext cx="10698480" cy="320040"/>
           </a:xfrm>
           <a:prstGeom prst="rect">
             <a:avLst/>
@@ -9937,7 +9409,7 @@
       </p:sp>
       <p:sp>
         <p:nvSpPr>
-          <p:cNvPr id="8" name="Rounded Rectangle 7"/>
+          <p:cNvPr id="6" name="Rounded Rectangle 5"/>
           <p:cNvSpPr/>
           <p:nvPr/>
         </p:nvSpPr>
@@ -10014,7 +9486,7 @@
       </p:sp>
       <p:sp>
         <p:nvSpPr>
-          <p:cNvPr id="9" name="Rounded Rectangle 8"/>
+          <p:cNvPr id="7" name="Rounded Rectangle 6"/>
           <p:cNvSpPr/>
           <p:nvPr/>
         </p:nvSpPr>
@@ -10091,7 +9563,7 @@
       </p:sp>
       <p:sp>
         <p:nvSpPr>
-          <p:cNvPr id="10" name="Rounded Rectangle 9"/>
+          <p:cNvPr id="8" name="Rounded Rectangle 7"/>
           <p:cNvSpPr/>
           <p:nvPr/>
         </p:nvSpPr>
@@ -10279,7 +9751,7 @@
         <p:spPr>
           <a:xfrm>
             <a:off x="731520" y="320040"/>
-            <a:ext cx="7772400" cy="777240"/>
+            <a:ext cx="10698480" cy="777240"/>
           </a:xfrm>
           <a:prstGeom prst="rect">
             <a:avLst/>
@@ -10306,64 +9778,16 @@
           </a:p>
         </p:txBody>
       </p:sp>
-      <p:pic>
-        <p:nvPicPr>
-          <p:cNvPr id="5" name="Picture 4" descr="gtu_logo.png"/>
-          <p:cNvPicPr>
-            <a:picLocks noChangeAspect="1"/>
-          </p:cNvPicPr>
-          <p:nvPr/>
-        </p:nvPicPr>
-        <p:blipFill>
-          <a:blip r:embed="rId2"/>
-          <a:stretch>
-            <a:fillRect/>
-          </a:stretch>
-        </p:blipFill>
-        <p:spPr>
-          <a:xfrm>
-            <a:off x="10241280" y="182880"/>
-            <a:ext cx="731520" cy="822960"/>
-          </a:xfrm>
-          <a:prstGeom prst="rect">
-            <a:avLst/>
-          </a:prstGeom>
-        </p:spPr>
-      </p:pic>
-      <p:pic>
-        <p:nvPicPr>
-          <p:cNvPr id="6" name="Picture 5" descr="kdp_patan_logo.png"/>
-          <p:cNvPicPr>
-            <a:picLocks noChangeAspect="1"/>
-          </p:cNvPicPr>
-          <p:nvPr/>
-        </p:nvPicPr>
-        <p:blipFill>
-          <a:blip r:embed="rId3"/>
-          <a:stretch>
-            <a:fillRect/>
-          </a:stretch>
-        </p:blipFill>
-        <p:spPr>
-          <a:xfrm>
-            <a:off x="11155680" y="182880"/>
-            <a:ext cx="777240" cy="777240"/>
-          </a:xfrm>
-          <a:prstGeom prst="rect">
-            <a:avLst/>
-          </a:prstGeom>
-        </p:spPr>
-      </p:pic>
-      <p:sp>
-        <p:nvSpPr>
-          <p:cNvPr id="7" name="TextBox 6"/>
+      <p:sp>
+        <p:nvSpPr>
+          <p:cNvPr id="5" name="TextBox 4"/>
           <p:cNvSpPr txBox="1"/>
           <p:nvPr/>
         </p:nvSpPr>
         <p:spPr>
           <a:xfrm>
             <a:off x="731520" y="960120"/>
-            <a:ext cx="9144000" cy="320040"/>
+            <a:ext cx="10698480" cy="320040"/>
           </a:xfrm>
           <a:prstGeom prst="rect">
             <a:avLst/>
@@ -10392,7 +9816,7 @@
       </p:sp>
       <p:graphicFrame>
         <p:nvGraphicFramePr>
-          <p:cNvPr id="8" name="Table 7"/>
+          <p:cNvPr id="6" name="Table 5"/>
           <p:cNvGraphicFramePr>
             <a:graphicFrameLocks noGrp="1"/>
           </p:cNvGraphicFramePr>
@@ -11031,7 +10455,7 @@
       </p:graphicFrame>
       <p:sp>
         <p:nvSpPr>
-          <p:cNvPr id="9" name="TextBox 8"/>
+          <p:cNvPr id="7" name="TextBox 6"/>
           <p:cNvSpPr txBox="1"/>
           <p:nvPr/>
         </p:nvSpPr>
@@ -11178,7 +10602,7 @@
         <p:spPr>
           <a:xfrm>
             <a:off x="731520" y="320040"/>
-            <a:ext cx="7772400" cy="777240"/>
+            <a:ext cx="10698480" cy="777240"/>
           </a:xfrm>
           <a:prstGeom prst="rect">
             <a:avLst/>
@@ -11205,64 +10629,16 @@
           </a:p>
         </p:txBody>
       </p:sp>
-      <p:pic>
-        <p:nvPicPr>
-          <p:cNvPr id="5" name="Picture 4" descr="gtu_logo.png"/>
-          <p:cNvPicPr>
-            <a:picLocks noChangeAspect="1"/>
-          </p:cNvPicPr>
-          <p:nvPr/>
-        </p:nvPicPr>
-        <p:blipFill>
-          <a:blip r:embed="rId2"/>
-          <a:stretch>
-            <a:fillRect/>
-          </a:stretch>
-        </p:blipFill>
-        <p:spPr>
-          <a:xfrm>
-            <a:off x="10241280" y="182880"/>
-            <a:ext cx="731520" cy="822960"/>
-          </a:xfrm>
-          <a:prstGeom prst="rect">
-            <a:avLst/>
-          </a:prstGeom>
-        </p:spPr>
-      </p:pic>
-      <p:pic>
-        <p:nvPicPr>
-          <p:cNvPr id="6" name="Picture 5" descr="kdp_patan_logo.png"/>
-          <p:cNvPicPr>
-            <a:picLocks noChangeAspect="1"/>
-          </p:cNvPicPr>
-          <p:nvPr/>
-        </p:nvPicPr>
-        <p:blipFill>
-          <a:blip r:embed="rId3"/>
-          <a:stretch>
-            <a:fillRect/>
-          </a:stretch>
-        </p:blipFill>
-        <p:spPr>
-          <a:xfrm>
-            <a:off x="11155680" y="182880"/>
-            <a:ext cx="777240" cy="777240"/>
-          </a:xfrm>
-          <a:prstGeom prst="rect">
-            <a:avLst/>
-          </a:prstGeom>
-        </p:spPr>
-      </p:pic>
-      <p:sp>
-        <p:nvSpPr>
-          <p:cNvPr id="7" name="TextBox 6"/>
+      <p:sp>
+        <p:nvSpPr>
+          <p:cNvPr id="5" name="TextBox 4"/>
           <p:cNvSpPr txBox="1"/>
           <p:nvPr/>
         </p:nvSpPr>
         <p:spPr>
           <a:xfrm>
             <a:off x="731520" y="960120"/>
-            <a:ext cx="9144000" cy="320040"/>
+            <a:ext cx="10698480" cy="320040"/>
           </a:xfrm>
           <a:prstGeom prst="rect">
             <a:avLst/>
@@ -11291,7 +10667,7 @@
       </p:sp>
       <p:graphicFrame>
         <p:nvGraphicFramePr>
-          <p:cNvPr id="8" name="Table 7"/>
+          <p:cNvPr id="6" name="Table 5"/>
           <p:cNvGraphicFramePr>
             <a:graphicFrameLocks noGrp="1"/>
           </p:cNvGraphicFramePr>
@@ -11809,7 +11185,7 @@
       </p:graphicFrame>
       <p:sp>
         <p:nvSpPr>
-          <p:cNvPr id="9" name="TextBox 8"/>
+          <p:cNvPr id="7" name="TextBox 6"/>
           <p:cNvSpPr txBox="1"/>
           <p:nvPr/>
         </p:nvSpPr>
@@ -11969,7 +11345,7 @@
         <p:spPr>
           <a:xfrm>
             <a:off x="731520" y="320040"/>
-            <a:ext cx="7772400" cy="777240"/>
+            <a:ext cx="10698480" cy="777240"/>
           </a:xfrm>
           <a:prstGeom prst="rect">
             <a:avLst/>
@@ -11996,64 +11372,16 @@
           </a:p>
         </p:txBody>
       </p:sp>
-      <p:pic>
-        <p:nvPicPr>
-          <p:cNvPr id="5" name="Picture 4" descr="gtu_logo.png"/>
-          <p:cNvPicPr>
-            <a:picLocks noChangeAspect="1"/>
-          </p:cNvPicPr>
-          <p:nvPr/>
-        </p:nvPicPr>
-        <p:blipFill>
-          <a:blip r:embed="rId2"/>
-          <a:stretch>
-            <a:fillRect/>
-          </a:stretch>
-        </p:blipFill>
-        <p:spPr>
-          <a:xfrm>
-            <a:off x="10241280" y="182880"/>
-            <a:ext cx="731520" cy="822960"/>
-          </a:xfrm>
-          <a:prstGeom prst="rect">
-            <a:avLst/>
-          </a:prstGeom>
-        </p:spPr>
-      </p:pic>
-      <p:pic>
-        <p:nvPicPr>
-          <p:cNvPr id="6" name="Picture 5" descr="kdp_patan_logo.png"/>
-          <p:cNvPicPr>
-            <a:picLocks noChangeAspect="1"/>
-          </p:cNvPicPr>
-          <p:nvPr/>
-        </p:nvPicPr>
-        <p:blipFill>
-          <a:blip r:embed="rId3"/>
-          <a:stretch>
-            <a:fillRect/>
-          </a:stretch>
-        </p:blipFill>
-        <p:spPr>
-          <a:xfrm>
-            <a:off x="11155680" y="182880"/>
-            <a:ext cx="777240" cy="777240"/>
-          </a:xfrm>
-          <a:prstGeom prst="rect">
-            <a:avLst/>
-          </a:prstGeom>
-        </p:spPr>
-      </p:pic>
-      <p:sp>
-        <p:nvSpPr>
-          <p:cNvPr id="7" name="TextBox 6"/>
+      <p:sp>
+        <p:nvSpPr>
+          <p:cNvPr id="5" name="TextBox 4"/>
           <p:cNvSpPr txBox="1"/>
           <p:nvPr/>
         </p:nvSpPr>
         <p:spPr>
           <a:xfrm>
             <a:off x="731520" y="960120"/>
-            <a:ext cx="9144000" cy="320040"/>
+            <a:ext cx="10698480" cy="320040"/>
           </a:xfrm>
           <a:prstGeom prst="rect">
             <a:avLst/>
@@ -12082,7 +11410,7 @@
       </p:sp>
       <p:sp>
         <p:nvSpPr>
-          <p:cNvPr id="8" name="Rounded Rectangle 7"/>
+          <p:cNvPr id="6" name="Rounded Rectangle 5"/>
           <p:cNvSpPr/>
           <p:nvPr/>
         </p:nvSpPr>
@@ -12163,7 +11491,7 @@
       </p:sp>
       <p:sp>
         <p:nvSpPr>
-          <p:cNvPr id="9" name="Rounded Rectangle 8"/>
+          <p:cNvPr id="7" name="Rounded Rectangle 6"/>
           <p:cNvSpPr/>
           <p:nvPr/>
         </p:nvSpPr>
@@ -12248,7 +11576,7 @@
       </p:sp>
       <p:sp>
         <p:nvSpPr>
-          <p:cNvPr id="10" name="Rounded Rectangle 9"/>
+          <p:cNvPr id="8" name="Rounded Rectangle 7"/>
           <p:cNvSpPr/>
           <p:nvPr/>
         </p:nvSpPr>
@@ -12444,7 +11772,7 @@
         <p:spPr>
           <a:xfrm>
             <a:off x="731520" y="320040"/>
-            <a:ext cx="7772400" cy="777240"/>
+            <a:ext cx="10698480" cy="777240"/>
           </a:xfrm>
           <a:prstGeom prst="rect">
             <a:avLst/>
@@ -12471,64 +11799,16 @@
           </a:p>
         </p:txBody>
       </p:sp>
-      <p:pic>
-        <p:nvPicPr>
-          <p:cNvPr id="5" name="Picture 4" descr="gtu_logo.png"/>
-          <p:cNvPicPr>
-            <a:picLocks noChangeAspect="1"/>
-          </p:cNvPicPr>
-          <p:nvPr/>
-        </p:nvPicPr>
-        <p:blipFill>
-          <a:blip r:embed="rId2"/>
-          <a:stretch>
-            <a:fillRect/>
-          </a:stretch>
-        </p:blipFill>
-        <p:spPr>
-          <a:xfrm>
-            <a:off x="10241280" y="182880"/>
-            <a:ext cx="731520" cy="822960"/>
-          </a:xfrm>
-          <a:prstGeom prst="rect">
-            <a:avLst/>
-          </a:prstGeom>
-        </p:spPr>
-      </p:pic>
-      <p:pic>
-        <p:nvPicPr>
-          <p:cNvPr id="6" name="Picture 5" descr="kdp_patan_logo.png"/>
-          <p:cNvPicPr>
-            <a:picLocks noChangeAspect="1"/>
-          </p:cNvPicPr>
-          <p:nvPr/>
-        </p:nvPicPr>
-        <p:blipFill>
-          <a:blip r:embed="rId3"/>
-          <a:stretch>
-            <a:fillRect/>
-          </a:stretch>
-        </p:blipFill>
-        <p:spPr>
-          <a:xfrm>
-            <a:off x="11155680" y="182880"/>
-            <a:ext cx="777240" cy="777240"/>
-          </a:xfrm>
-          <a:prstGeom prst="rect">
-            <a:avLst/>
-          </a:prstGeom>
-        </p:spPr>
-      </p:pic>
-      <p:sp>
-        <p:nvSpPr>
-          <p:cNvPr id="7" name="TextBox 6"/>
+      <p:sp>
+        <p:nvSpPr>
+          <p:cNvPr id="5" name="TextBox 4"/>
           <p:cNvSpPr txBox="1"/>
           <p:nvPr/>
         </p:nvSpPr>
         <p:spPr>
           <a:xfrm>
             <a:off x="731520" y="960120"/>
-            <a:ext cx="9144000" cy="320040"/>
+            <a:ext cx="10698480" cy="320040"/>
           </a:xfrm>
           <a:prstGeom prst="rect">
             <a:avLst/>
@@ -12557,7 +11837,7 @@
       </p:sp>
       <p:sp>
         <p:nvSpPr>
-          <p:cNvPr id="8" name="Rounded Rectangle 7"/>
+          <p:cNvPr id="6" name="Rounded Rectangle 5"/>
           <p:cNvSpPr/>
           <p:nvPr/>
         </p:nvSpPr>
@@ -12634,7 +11914,7 @@
       </p:sp>
       <p:sp>
         <p:nvSpPr>
-          <p:cNvPr id="9" name="Rounded Rectangle 8"/>
+          <p:cNvPr id="7" name="Rounded Rectangle 6"/>
           <p:cNvSpPr/>
           <p:nvPr/>
         </p:nvSpPr>
@@ -12715,7 +11995,7 @@
       </p:sp>
       <p:sp>
         <p:nvSpPr>
-          <p:cNvPr id="10" name="Rounded Rectangle 9"/>
+          <p:cNvPr id="8" name="Rounded Rectangle 7"/>
           <p:cNvSpPr/>
           <p:nvPr/>
         </p:nvSpPr>
@@ -12907,7 +12187,7 @@
         <p:spPr>
           <a:xfrm>
             <a:off x="731520" y="320040"/>
-            <a:ext cx="7772400" cy="777240"/>
+            <a:ext cx="10698480" cy="777240"/>
           </a:xfrm>
           <a:prstGeom prst="rect">
             <a:avLst/>
@@ -12934,64 +12214,16 @@
           </a:p>
         </p:txBody>
       </p:sp>
-      <p:pic>
-        <p:nvPicPr>
-          <p:cNvPr id="5" name="Picture 4" descr="gtu_logo.png"/>
-          <p:cNvPicPr>
-            <a:picLocks noChangeAspect="1"/>
-          </p:cNvPicPr>
-          <p:nvPr/>
-        </p:nvPicPr>
-        <p:blipFill>
-          <a:blip r:embed="rId2"/>
-          <a:stretch>
-            <a:fillRect/>
-          </a:stretch>
-        </p:blipFill>
-        <p:spPr>
-          <a:xfrm>
-            <a:off x="10241280" y="182880"/>
-            <a:ext cx="731520" cy="822960"/>
-          </a:xfrm>
-          <a:prstGeom prst="rect">
-            <a:avLst/>
-          </a:prstGeom>
-        </p:spPr>
-      </p:pic>
-      <p:pic>
-        <p:nvPicPr>
-          <p:cNvPr id="6" name="Picture 5" descr="kdp_patan_logo.png"/>
-          <p:cNvPicPr>
-            <a:picLocks noChangeAspect="1"/>
-          </p:cNvPicPr>
-          <p:nvPr/>
-        </p:nvPicPr>
-        <p:blipFill>
-          <a:blip r:embed="rId3"/>
-          <a:stretch>
-            <a:fillRect/>
-          </a:stretch>
-        </p:blipFill>
-        <p:spPr>
-          <a:xfrm>
-            <a:off x="11155680" y="182880"/>
-            <a:ext cx="777240" cy="777240"/>
-          </a:xfrm>
-          <a:prstGeom prst="rect">
-            <a:avLst/>
-          </a:prstGeom>
-        </p:spPr>
-      </p:pic>
-      <p:sp>
-        <p:nvSpPr>
-          <p:cNvPr id="7" name="TextBox 6"/>
+      <p:sp>
+        <p:nvSpPr>
+          <p:cNvPr id="5" name="TextBox 4"/>
           <p:cNvSpPr txBox="1"/>
           <p:nvPr/>
         </p:nvSpPr>
         <p:spPr>
           <a:xfrm>
             <a:off x="731520" y="960120"/>
-            <a:ext cx="9144000" cy="320040"/>
+            <a:ext cx="10698480" cy="320040"/>
           </a:xfrm>
           <a:prstGeom prst="rect">
             <a:avLst/>
@@ -13020,7 +12252,7 @@
       </p:sp>
       <p:sp>
         <p:nvSpPr>
-          <p:cNvPr id="8" name="TextBox 7"/>
+          <p:cNvPr id="6" name="TextBox 5"/>
           <p:cNvSpPr txBox="1"/>
           <p:nvPr/>
         </p:nvSpPr>

</xml_diff>

<commit_message>
docs(presentation): upgrade presentation typography with large high-impact fonts, real prototype photos on slide 12, and commit assets
</commit_message>
<xml_diff>
--- a/docs/DineFlow_AI_GTU_Minor_Project_Presentation.pptx
+++ b/docs/DineFlow_AI_GTU_Minor_Project_Presentation.pptx
@@ -3190,9 +3190,57 @@
           </a:p>
         </p:txBody>
       </p:sp>
-      <p:sp>
-        <p:nvSpPr>
-          <p:cNvPr id="4" name="TextBox 3"/>
+      <p:pic>
+        <p:nvPicPr>
+          <p:cNvPr id="4" name="Picture 3" descr="gtu_logo.png"/>
+          <p:cNvPicPr>
+            <a:picLocks noChangeAspect="1"/>
+          </p:cNvPicPr>
+          <p:nvPr/>
+        </p:nvPicPr>
+        <p:blipFill>
+          <a:blip r:embed="rId2"/>
+          <a:stretch>
+            <a:fillRect/>
+          </a:stretch>
+        </p:blipFill>
+        <p:spPr>
+          <a:xfrm>
+            <a:off x="731520" y="365760"/>
+            <a:ext cx="1463040" cy="1645920"/>
+          </a:xfrm>
+          <a:prstGeom prst="rect">
+            <a:avLst/>
+          </a:prstGeom>
+        </p:spPr>
+      </p:pic>
+      <p:pic>
+        <p:nvPicPr>
+          <p:cNvPr id="5" name="Picture 4" descr="kdp_logo.png"/>
+          <p:cNvPicPr>
+            <a:picLocks noChangeAspect="1"/>
+          </p:cNvPicPr>
+          <p:nvPr/>
+        </p:nvPicPr>
+        <p:blipFill>
+          <a:blip r:embed="rId3"/>
+          <a:stretch>
+            <a:fillRect/>
+          </a:stretch>
+        </p:blipFill>
+        <p:spPr>
+          <a:xfrm>
+            <a:off x="9966960" y="365760"/>
+            <a:ext cx="1463040" cy="1463040"/>
+          </a:xfrm>
+          <a:prstGeom prst="rect">
+            <a:avLst/>
+          </a:prstGeom>
+        </p:spPr>
+      </p:pic>
+      <p:sp>
+        <p:nvSpPr>
+          <p:cNvPr id="6" name="TextBox 5"/>
           <p:cNvSpPr txBox="1"/>
           <p:nvPr/>
         </p:nvSpPr>
@@ -3267,7 +3315,7 @@
       </p:sp>
       <p:sp>
         <p:nvSpPr>
-          <p:cNvPr id="5" name="Rounded Rectangle 4"/>
+          <p:cNvPr id="7" name="Rounded Rectangle 6"/>
           <p:cNvSpPr/>
           <p:nvPr/>
         </p:nvSpPr>
@@ -3335,7 +3383,7 @@
       </p:sp>
       <p:sp>
         <p:nvSpPr>
-          <p:cNvPr id="6" name="Rounded Rectangle 5"/>
+          <p:cNvPr id="8" name="Rounded Rectangle 7"/>
           <p:cNvSpPr/>
           <p:nvPr/>
         </p:nvSpPr>
@@ -3494,7 +3542,7 @@
       </p:sp>
       <p:sp>
         <p:nvSpPr>
-          <p:cNvPr id="7" name="Rounded Rectangle 6"/>
+          <p:cNvPr id="9" name="Rounded Rectangle 8"/>
           <p:cNvSpPr/>
           <p:nvPr/>
         </p:nvSpPr>
@@ -5429,7 +5477,7 @@
           <a:lstStyle/>
           <a:p>
             <a:pPr algn="ctr">
-              <a:defRPr b="1" sz="1600">
+              <a:defRPr b="1" sz="1500">
                 <a:solidFill>
                   <a:srgbClr val="0F172A"/>
                 </a:solidFill>
@@ -5442,100 +5490,145 @@
           </a:p>
           <a:p>
             <a:pPr algn="ctr">
+              <a:defRPr b="1" sz="1200">
+                <a:solidFill>
+                  <a:srgbClr val="4338CA"/>
+                </a:solidFill>
+                <a:latin typeface="Calibri"/>
+              </a:defRPr>
+            </a:pPr>
+            <a:r>
+              <a:t>Figure 4(a): UI Operational</a:t>
+            </a:r>
+          </a:p>
+        </p:txBody>
+      </p:sp>
+      <p:pic>
+        <p:nvPicPr>
+          <p:cNvPr id="7" name="Picture 6" descr="web_pos_interface.png"/>
+          <p:cNvPicPr>
+            <a:picLocks noChangeAspect="1"/>
+          </p:cNvPicPr>
+          <p:nvPr/>
+        </p:nvPicPr>
+        <p:blipFill>
+          <a:blip r:embed="rId2"/>
+          <a:stretch>
+            <a:fillRect/>
+          </a:stretch>
+        </p:blipFill>
+        <p:spPr>
+          <a:xfrm>
+            <a:off x="868680" y="2148840"/>
+            <a:ext cx="3200400" cy="1920240"/>
+          </a:xfrm>
+          <a:prstGeom prst="rect">
+            <a:avLst/>
+          </a:prstGeom>
+        </p:spPr>
+      </p:pic>
+      <p:sp>
+        <p:nvSpPr>
+          <p:cNvPr id="8" name="TextBox 7"/>
+          <p:cNvSpPr txBox="1"/>
+          <p:nvPr/>
+        </p:nvSpPr>
+        <p:spPr>
+          <a:xfrm>
+            <a:off x="777240" y="4160520"/>
+            <a:ext cx="3383280" cy="2103120"/>
+          </a:xfrm>
+          <a:prstGeom prst="rect">
+            <a:avLst/>
+          </a:prstGeom>
+          <a:noFill/>
+        </p:spPr>
+        <p:txBody>
+          <a:bodyPr wrap="square">
+            <a:spAutoFit/>
+          </a:bodyPr>
+          <a:lstStyle/>
+          <a:p/>
+          <a:p>
+            <a:pPr>
               <a:spcAft>
-                <a:spcPts val="1200"/>
+                <a:spcPts val="400"/>
               </a:spcAft>
-              <a:defRPr b="1" sz="1250">
+            </a:pPr>
+            <a:r>
+              <a:rPr b="1" sz="1200">
                 <a:solidFill>
                   <a:srgbClr val="4338CA"/>
                 </a:solidFill>
                 <a:latin typeface="Calibri"/>
-              </a:defRPr>
-            </a:pPr>
-            <a:r>
-              <a:t>Figure 4(a): UI Operational</a:t>
+              </a:rPr>
+              <a:t>• Touch-Optimized UI: </a:t>
+            </a:r>
+            <a:r>
+              <a:rPr b="0" sz="1200">
+                <a:solidFill>
+                  <a:srgbClr val="1E293B"/>
+                </a:solidFill>
+                <a:latin typeface="Calibri"/>
+              </a:rPr>
+              <a:t>Category chips and instant search.</a:t>
             </a:r>
           </a:p>
           <a:p>
             <a:pPr>
               <a:spcAft>
-                <a:spcPts val="1000"/>
+                <a:spcPts val="400"/>
               </a:spcAft>
             </a:pPr>
             <a:r>
-              <a:rPr b="1" sz="1300">
-                <a:solidFill>
-                  <a:srgbClr val="0F172A"/>
-                </a:solidFill>
-                <a:latin typeface="Calibri"/>
-              </a:rPr>
-              <a:t>• Touch-Optimized Layout: </a:t>
-            </a:r>
-            <a:r>
-              <a:rPr b="0" sz="1300">
+              <a:rPr b="1" sz="1200">
+                <a:solidFill>
+                  <a:srgbClr val="4338CA"/>
+                </a:solidFill>
+                <a:latin typeface="Calibri"/>
+              </a:rPr>
+              <a:t>• Rapid Checkout: </a:t>
+            </a:r>
+            <a:r>
+              <a:rPr b="0" sz="1200">
                 <a:solidFill>
                   <a:srgbClr val="1E293B"/>
                 </a:solidFill>
                 <a:latin typeface="Calibri"/>
               </a:rPr>
-              <a:t>Category pills, instant search, and split-second item selection.</a:t>
+              <a:t>Instant billing with auto-GST computation.</a:t>
             </a:r>
           </a:p>
           <a:p>
             <a:pPr>
               <a:spcAft>
-                <a:spcPts val="1000"/>
+                <a:spcPts val="400"/>
               </a:spcAft>
             </a:pPr>
             <a:r>
-              <a:rPr b="1" sz="1300">
-                <a:solidFill>
-                  <a:srgbClr val="0F172A"/>
-                </a:solidFill>
-                <a:latin typeface="Calibri"/>
-              </a:rPr>
-              <a:t>• Split-Second Checkout: </a:t>
-            </a:r>
-            <a:r>
-              <a:rPr b="0" sz="1300">
+              <a:rPr b="1" sz="1200">
+                <a:solidFill>
+                  <a:srgbClr val="4338CA"/>
+                </a:solidFill>
+                <a:latin typeface="Calibri"/>
+              </a:rPr>
+              <a:t>• Offline Resilience: </a:t>
+            </a:r>
+            <a:r>
+              <a:rPr b="0" sz="1200">
                 <a:solidFill>
                   <a:srgbClr val="1E293B"/>
                 </a:solidFill>
                 <a:latin typeface="Calibri"/>
               </a:rPr>
-              <a:t>Instant cash/card/UPI checkout with automatic GST receipt generation.</a:t>
-            </a:r>
-          </a:p>
-          <a:p>
-            <a:pPr>
-              <a:spcAft>
-                <a:spcPts val="1000"/>
-              </a:spcAft>
-            </a:pPr>
-            <a:r>
-              <a:rPr b="1" sz="1300">
-                <a:solidFill>
-                  <a:srgbClr val="0F172A"/>
-                </a:solidFill>
-                <a:latin typeface="Calibri"/>
-              </a:rPr>
-              <a:t>• Offline PWA Caching: </a:t>
-            </a:r>
-            <a:r>
-              <a:rPr b="0" sz="1300">
-                <a:solidFill>
-                  <a:srgbClr val="1E293B"/>
-                </a:solidFill>
-                <a:latin typeface="Calibri"/>
-              </a:rPr>
-              <a:t>Continues recording orders even during brief WiFi interruptions.</a:t>
-            </a:r>
-          </a:p>
-        </p:txBody>
-      </p:sp>
-      <p:sp>
-        <p:nvSpPr>
-          <p:cNvPr id="7" name="Rounded Rectangle 6"/>
+              <a:t>Continues recording if WiFi drops.</a:t>
+            </a:r>
+          </a:p>
+        </p:txBody>
+      </p:sp>
+      <p:sp>
+        <p:nvSpPr>
+          <p:cNvPr id="9" name="Rounded Rectangle 8"/>
           <p:cNvSpPr/>
           <p:nvPr/>
         </p:nvSpPr>
@@ -5575,7 +5668,20 @@
           <a:lstStyle/>
           <a:p>
             <a:pPr algn="ctr">
-              <a:defRPr b="1" sz="1600">
+              <a:defRPr b="1" sz="1500">
+                <a:solidFill>
+                  <a:srgbClr val="0F172A"/>
+                </a:solidFill>
+                <a:latin typeface="Calibri"/>
+              </a:defRPr>
+            </a:pPr>
+            <a:r>
+              <a:t>ESC/POS Thermal Hardware</a:t>
+            </a:r>
+          </a:p>
+          <a:p>
+            <a:pPr algn="ctr">
+              <a:defRPr b="1" sz="1200">
                 <a:solidFill>
                   <a:srgbClr val="4338CA"/>
                 </a:solidFill>
@@ -5583,105 +5689,137 @@
               </a:defRPr>
             </a:pPr>
             <a:r>
-              <a:t>ESC/POS Thermal Hardware</a:t>
-            </a:r>
-          </a:p>
-          <a:p>
-            <a:pPr algn="ctr">
+              <a:t>Figure 4(b): Hardware Interfaced</a:t>
+            </a:r>
+          </a:p>
+        </p:txBody>
+      </p:sp>
+      <p:pic>
+        <p:nvPicPr>
+          <p:cNvPr id="10" name="Picture 9" descr="escpos_printer_setup.png"/>
+          <p:cNvPicPr>
+            <a:picLocks noChangeAspect="1"/>
+          </p:cNvPicPr>
+          <p:nvPr/>
+        </p:nvPicPr>
+        <p:blipFill>
+          <a:blip r:embed="rId3"/>
+          <a:stretch>
+            <a:fillRect/>
+          </a:stretch>
+        </p:blipFill>
+        <p:spPr>
+          <a:xfrm>
+            <a:off x="4480560" y="2148840"/>
+            <a:ext cx="3200400" cy="1920240"/>
+          </a:xfrm>
+          <a:prstGeom prst="rect">
+            <a:avLst/>
+          </a:prstGeom>
+        </p:spPr>
+      </p:pic>
+      <p:sp>
+        <p:nvSpPr>
+          <p:cNvPr id="11" name="TextBox 10"/>
+          <p:cNvSpPr txBox="1"/>
+          <p:nvPr/>
+        </p:nvSpPr>
+        <p:spPr>
+          <a:xfrm>
+            <a:off x="4389120" y="4160520"/>
+            <a:ext cx="3383280" cy="2103120"/>
+          </a:xfrm>
+          <a:prstGeom prst="rect">
+            <a:avLst/>
+          </a:prstGeom>
+          <a:noFill/>
+        </p:spPr>
+        <p:txBody>
+          <a:bodyPr wrap="square">
+            <a:spAutoFit/>
+          </a:bodyPr>
+          <a:lstStyle/>
+          <a:p/>
+          <a:p>
+            <a:pPr>
               <a:spcAft>
-                <a:spcPts val="1200"/>
+                <a:spcPts val="400"/>
               </a:spcAft>
-              <a:defRPr b="1" sz="1250">
+            </a:pPr>
+            <a:r>
+              <a:rPr b="1" sz="1200">
                 <a:solidFill>
                   <a:srgbClr val="4338CA"/>
                 </a:solidFill>
                 <a:latin typeface="Calibri"/>
-              </a:defRPr>
-            </a:pPr>
-            <a:r>
-              <a:t>Figure 4(b): Hardware Interfaced</a:t>
+              </a:rPr>
+              <a:t>• Direct ESC/POS Driver: </a:t>
+            </a:r>
+            <a:r>
+              <a:rPr b="0" sz="1200">
+                <a:solidFill>
+                  <a:srgbClr val="1E293B"/>
+                </a:solidFill>
+                <a:latin typeface="Calibri"/>
+              </a:rPr>
+              <a:t>Raw Web USB and Bluetooth streaming.</a:t>
             </a:r>
           </a:p>
           <a:p>
             <a:pPr>
               <a:spcAft>
-                <a:spcPts val="1000"/>
+                <a:spcPts val="400"/>
               </a:spcAft>
             </a:pPr>
             <a:r>
-              <a:rPr b="1" sz="1300">
+              <a:rPr b="1" sz="1200">
                 <a:solidFill>
                   <a:srgbClr val="4338CA"/>
                 </a:solidFill>
                 <a:latin typeface="Calibri"/>
               </a:rPr>
-              <a:t>• Direct Browser Print: </a:t>
-            </a:r>
-            <a:r>
-              <a:rPr b="0" sz="1300">
+              <a:t>• Silent Zero-Click Print: </a:t>
+            </a:r>
+            <a:r>
+              <a:rPr b="0" sz="1200">
                 <a:solidFill>
                   <a:srgbClr val="1E293B"/>
                 </a:solidFill>
                 <a:latin typeface="Calibri"/>
               </a:rPr>
-              <a:t>Raw ESC/POS byte streaming via Web USB and Bluetooth.</a:t>
+              <a:t>Bypasses browser print modal.</a:t>
             </a:r>
           </a:p>
           <a:p>
             <a:pPr>
               <a:spcAft>
-                <a:spcPts val="1000"/>
+                <a:spcPts val="400"/>
               </a:spcAft>
             </a:pPr>
             <a:r>
-              <a:rPr b="1" sz="1300">
+              <a:rPr b="1" sz="1200">
                 <a:solidFill>
                   <a:srgbClr val="4338CA"/>
                 </a:solidFill>
                 <a:latin typeface="Calibri"/>
               </a:rPr>
-              <a:t>• Silent Print Engine: </a:t>
-            </a:r>
-            <a:r>
-              <a:rPr b="0" sz="1300">
+              <a:t>• Dual Role Output: </a:t>
+            </a:r>
+            <a:r>
+              <a:rPr b="0" sz="1200">
                 <a:solidFill>
                   <a:srgbClr val="1E293B"/>
                 </a:solidFill>
                 <a:latin typeface="Calibri"/>
               </a:rPr>
-              <a:t>Bypasses browser print dialogues for instant high-speed counter printing.</a:t>
-            </a:r>
-          </a:p>
-          <a:p>
-            <a:pPr>
-              <a:spcAft>
-                <a:spcPts val="1000"/>
-              </a:spcAft>
-            </a:pPr>
-            <a:r>
-              <a:rPr b="1" sz="1300">
-                <a:solidFill>
-                  <a:srgbClr val="4338CA"/>
-                </a:solidFill>
-                <a:latin typeface="Calibri"/>
-              </a:rPr>
-              <a:t>• Dual-Role Capability: </a:t>
-            </a:r>
-            <a:r>
-              <a:rPr b="0" sz="1300">
-                <a:solidFill>
-                  <a:srgbClr val="1E293B"/>
-                </a:solidFill>
-                <a:latin typeface="Calibri"/>
-              </a:rPr>
-              <a:t>Prints 58mm customer receipts and 80mm kitchen KOT slips.</a:t>
-            </a:r>
-          </a:p>
-        </p:txBody>
-      </p:sp>
-      <p:sp>
-        <p:nvSpPr>
-          <p:cNvPr id="8" name="Rounded Rectangle 7"/>
+              <a:t>58mm bills and 80mm kitchen KOT slips.</a:t>
+            </a:r>
+          </a:p>
+        </p:txBody>
+      </p:sp>
+      <p:sp>
+        <p:nvSpPr>
+          <p:cNvPr id="12" name="Rounded Rectangle 11"/>
           <p:cNvSpPr/>
           <p:nvPr/>
         </p:nvSpPr>
@@ -5694,11 +5832,11 @@
             <a:avLst/>
           </a:prstGeom>
           <a:solidFill>
-            <a:srgbClr val="F8FAFC"/>
+            <a:srgbClr val="ECFDF5"/>
           </a:solidFill>
-          <a:ln>
+          <a:ln w="19050">
             <a:solidFill>
-              <a:srgbClr val="CBD5E1"/>
+              <a:srgbClr val="059669"/>
             </a:solidFill>
           </a:ln>
         </p:spPr>
@@ -5735,11 +5873,11 @@
           <a:p>
             <a:pPr algn="ctr">
               <a:spcAft>
-                <a:spcPts val="1200"/>
+                <a:spcPts val="1600"/>
               </a:spcAft>
-              <a:defRPr b="1" sz="1250">
-                <a:solidFill>
-                  <a:srgbClr val="4338CA"/>
+              <a:defRPr b="1" sz="1300">
+                <a:solidFill>
+                  <a:srgbClr val="0F172A"/>
                 </a:solidFill>
                 <a:latin typeface="Calibri"/>
               </a:defRPr>
@@ -5751,7 +5889,7 @@
           <a:p>
             <a:pPr>
               <a:spcAft>
-                <a:spcPts val="1000"/>
+                <a:spcPts val="800"/>
               </a:spcAft>
             </a:pPr>
             <a:r>
@@ -5761,7 +5899,7 @@
                 </a:solidFill>
                 <a:latin typeface="Calibri"/>
               </a:rPr>
-              <a:t>• Live Cloud Instance: </a:t>
+              <a:t>• AWS Cloud VPS: </a:t>
             </a:r>
             <a:r>
               <a:rPr b="0" sz="1300">
@@ -5770,13 +5908,13 @@
                 </a:solidFill>
                 <a:latin typeface="Calibri"/>
               </a:rPr>
-              <a:t>Hosted on AWS EC2 Ubuntu 24.04 LTS at dineflowai.duckdns.org.</a:t>
+              <a:t>Ubuntu 24.04 LTS, Nginx, PHP 8.2, MySQL.</a:t>
             </a:r>
           </a:p>
           <a:p>
             <a:pPr>
               <a:spcAft>
-                <a:spcPts val="1000"/>
+                <a:spcPts val="800"/>
               </a:spcAft>
             </a:pPr>
             <a:r>
@@ -5786,7 +5924,7 @@
                 </a:solidFill>
                 <a:latin typeface="Calibri"/>
               </a:rPr>
-              <a:t>• A+ Security &amp; SSL: </a:t>
+              <a:t>• Production URL: </a:t>
             </a:r>
             <a:r>
               <a:rPr b="0" sz="1300">
@@ -5795,13 +5933,13 @@
                 </a:solidFill>
                 <a:latin typeface="Calibri"/>
               </a:rPr>
-              <a:t>Let's Encrypt TLS 1.3 with automated certificate renewal.</a:t>
+              <a:t>dineflowai.duckdns.org</a:t>
             </a:r>
           </a:p>
           <a:p>
             <a:pPr>
               <a:spcAft>
-                <a:spcPts val="1000"/>
+                <a:spcPts val="800"/>
               </a:spcAft>
             </a:pPr>
             <a:r>
@@ -5811,7 +5949,7 @@
                 </a:solidFill>
                 <a:latin typeface="Calibri"/>
               </a:rPr>
-              <a:t>• Multi-Device Verified: </a:t>
+              <a:t>• High-Grade Security: </a:t>
             </a:r>
             <a:r>
               <a:rPr b="0" sz="1300">
@@ -5820,7 +5958,57 @@
                 </a:solidFill>
                 <a:latin typeface="Calibri"/>
               </a:rPr>
-              <a:t>Tested across Android tablets, iOS phones, Windows PCs &amp; Mac.</a:t>
+              <a:t>Let's Encrypt TLS 1.3 with A+ rating.</a:t>
+            </a:r>
+          </a:p>
+          <a:p>
+            <a:pPr>
+              <a:spcAft>
+                <a:spcPts val="800"/>
+              </a:spcAft>
+            </a:pPr>
+            <a:r>
+              <a:rPr b="1" sz="1300">
+                <a:solidFill>
+                  <a:srgbClr val="059669"/>
+                </a:solidFill>
+                <a:latin typeface="Calibri"/>
+              </a:rPr>
+              <a:t>• Multi-Device Support: </a:t>
+            </a:r>
+            <a:r>
+              <a:rPr b="0" sz="1300">
+                <a:solidFill>
+                  <a:srgbClr val="1E293B"/>
+                </a:solidFill>
+                <a:latin typeface="Calibri"/>
+              </a:rPr>
+              <a:t>Works on Android, iOS, Windows, Mac.</a:t>
+            </a:r>
+          </a:p>
+          <a:p>
+            <a:pPr>
+              <a:spcAft>
+                <a:spcPts val="800"/>
+              </a:spcAft>
+            </a:pPr>
+            <a:r>
+              <a:rPr b="1" sz="1300">
+                <a:solidFill>
+                  <a:srgbClr val="059669"/>
+                </a:solidFill>
+                <a:latin typeface="Calibri"/>
+              </a:rPr>
+              <a:t>• Zero Extra Capex: </a:t>
+            </a:r>
+            <a:r>
+              <a:rPr b="0" sz="1300">
+                <a:solidFill>
+                  <a:srgbClr val="1E293B"/>
+                </a:solidFill>
+                <a:latin typeface="Calibri"/>
+              </a:rPr>
+              <a:t>No costly proprietary hardware needed.</a:t>
             </a:r>
           </a:p>
         </p:txBody>

</xml_diff>

<commit_message>
docs(gtu): generate official Minor Project Logbook matching college format and harmonize 15-week plan across report and presentation
</commit_message>
<xml_diff>
--- a/docs/DineFlow_AI_GTU_Minor_Project_Presentation.pptx
+++ b/docs/DineFlow_AI_GTU_Minor_Project_Presentation.pptx
@@ -4646,7 +4646,7 @@
               </a:defRPr>
             </a:pPr>
             <a:r>
-              <a:t>Work Plan (14-Week Semester Schedule)</a:t>
+              <a:t>Work Plan (15-Week Semester Schedule)</a:t>
             </a:r>
           </a:p>
         </p:txBody>
@@ -4818,7 +4818,7 @@
                           </a:solidFill>
                           <a:latin typeface="Calibri"/>
                         </a:rPr>
-                        <a:t>Weeks 1 - 2</a:t>
+                        <a:t>Weeks 1 - 3</a:t>
                       </a:r>
                     </a:p>
                   </a:txBody>
@@ -4862,7 +4862,7 @@
                           </a:solidFill>
                           <a:latin typeface="Calibri"/>
                         </a:rPr>
-                        <a:t>Restaurant visits, pain-point analysis, GTU scope finalization</a:t>
+                        <a:t>Restaurant visits, pain-point survey, SRS specification</a:t>
                       </a:r>
                     </a:p>
                   </a:txBody>
@@ -4908,7 +4908,7 @@
                           </a:solidFill>
                           <a:latin typeface="Calibri"/>
                         </a:rPr>
-                        <a:t>Weeks 3 - 5</a:t>
+                        <a:t>Weeks 4 - 6</a:t>
                       </a:r>
                     </a:p>
                   </a:txBody>
@@ -4952,7 +4952,7 @@
                           </a:solidFill>
                           <a:latin typeface="Calibri"/>
                         </a:rPr>
-                        <a:t>Multi-tenant DB schema, ER diagram, Livewire wireframes</a:t>
+                        <a:t>Multi-tenant DB schema, ER diagram, Laravel core setup</a:t>
                       </a:r>
                     </a:p>
                   </a:txBody>
@@ -4998,7 +4998,7 @@
                           </a:solidFill>
                           <a:latin typeface="Calibri"/>
                         </a:rPr>
-                        <a:t>Weeks 6 - 8</a:t>
+                        <a:t>Weeks 7 - 9</a:t>
                       </a:r>
                     </a:p>
                   </a:txBody>
@@ -5020,7 +5020,7 @@
                           </a:solidFill>
                           <a:latin typeface="Calibri"/>
                         </a:rPr>
-                        <a:t>Core Development &amp; ESC/POS</a:t>
+                        <a:t>Core Development &amp; Web POS</a:t>
                       </a:r>
                     </a:p>
                   </a:txBody>
@@ -5042,7 +5042,7 @@
                           </a:solidFill>
                           <a:latin typeface="Calibri"/>
                         </a:rPr>
-                        <a:t>QR menu, POS billing screen, ESC/POS direct thermal print</a:t>
+                        <a:t>QR menu, POS billing counter, ESC/POS direct thermal print</a:t>
                       </a:r>
                     </a:p>
                   </a:txBody>
@@ -5088,7 +5088,7 @@
                           </a:solidFill>
                           <a:latin typeface="Calibri"/>
                         </a:rPr>
-                        <a:t>Weeks 9 - 11</a:t>
+                        <a:t>Weeks 10 - 12</a:t>
                       </a:r>
                     </a:p>
                   </a:txBody>
@@ -5110,7 +5110,7 @@
                           </a:solidFill>
                           <a:latin typeface="Calibri"/>
                         </a:rPr>
-                        <a:t>KDS Sync &amp; Gujarati Audio</a:t>
+                        <a:t>KDS Sync, Soundbox &amp; Recipe ERP</a:t>
                       </a:r>
                     </a:p>
                   </a:txBody>
@@ -5132,7 +5132,7 @@
                           </a:solidFill>
                           <a:latin typeface="Calibri"/>
                         </a:rPr>
-                        <a:t>Live kitchen display queue, audio synthesis, recipe ERP</a:t>
+                        <a:t>Live kitchen display queue, Gujarati audio, recipe costing</a:t>
                       </a:r>
                     </a:p>
                   </a:txBody>
@@ -5178,7 +5178,7 @@
                           </a:solidFill>
                           <a:latin typeface="Calibri"/>
                         </a:rPr>
-                        <a:t>Weeks 12 - 14</a:t>
+                        <a:t>Weeks 13 - 15</a:t>
                       </a:r>
                     </a:p>
                   </a:txBody>
@@ -5200,7 +5200,7 @@
                           </a:solidFill>
                           <a:latin typeface="Calibri"/>
                         </a:rPr>
-                        <a:t>Security Auditing &amp; Documentation</a:t>
+                        <a:t>Security Auditing, Cloud &amp; Report</a:t>
                       </a:r>
                     </a:p>
                   </a:txBody>
@@ -5222,7 +5222,7 @@
                           </a:solidFill>
                           <a:latin typeface="Calibri"/>
                         </a:rPr>
-                        <a:t>IDOR vulnerability audit, GTU report writing &amp; viva prep</a:t>
+                        <a:t>IDOR vulnerability audit, AWS EC2 deployment, GTU Viva</a:t>
                       </a:r>
                     </a:p>
                   </a:txBody>

</xml_diff>

<commit_message>
docs(gtu): align Slide 3 industry stats and Slide 11 4-stage build sequence with GTU demo PPT template
</commit_message>
<xml_diff>
--- a/docs/DineFlow_AI_GTU_Minor_Project_Presentation.pptx
+++ b/docs/DineFlow_AI_GTU_Minor_Project_Presentation.pptx
@@ -4986,8 +4986,8 @@
         </p:blipFill>
         <p:spPr>
           <a:xfrm>
-            <a:off x="731520" y="1280160"/>
-            <a:ext cx="5120640" cy="3200400"/>
+            <a:off x="731520" y="1234440"/>
+            <a:ext cx="3840480" cy="2400300"/>
           </a:xfrm>
           <a:prstGeom prst="rect">
             <a:avLst/>
@@ -5010,8 +5010,8 @@
         </p:blipFill>
         <p:spPr>
           <a:xfrm>
-            <a:off x="6217920" y="1280160"/>
-            <a:ext cx="5257800" cy="3925824"/>
+            <a:off x="4754880" y="1234440"/>
+            <a:ext cx="3474720" cy="2594458"/>
           </a:xfrm>
           <a:prstGeom prst="rect">
             <a:avLst/>
@@ -5026,8 +5026,183 @@
         </p:nvSpPr>
         <p:spPr>
           <a:xfrm>
-            <a:off x="731520" y="4572000"/>
-            <a:ext cx="5120640" cy="1691640"/>
+            <a:off x="8412480" y="1234440"/>
+            <a:ext cx="3063240" cy="4937760"/>
+          </a:xfrm>
+          <a:prstGeom prst="roundRect">
+            <a:avLst/>
+          </a:prstGeom>
+          <a:solidFill>
+            <a:srgbClr val="F8FAFC"/>
+          </a:solidFill>
+          <a:ln w="19050">
+            <a:solidFill>
+              <a:srgbClr val="059669"/>
+            </a:solidFill>
+          </a:ln>
+        </p:spPr>
+        <p:style>
+          <a:lnRef idx="1">
+            <a:schemeClr val="accent1"/>
+          </a:lnRef>
+          <a:fillRef idx="3">
+            <a:schemeClr val="accent1"/>
+          </a:fillRef>
+          <a:effectRef idx="2">
+            <a:schemeClr val="accent1"/>
+          </a:effectRef>
+          <a:fontRef idx="minor">
+            <a:schemeClr val="lt1"/>
+          </a:fontRef>
+        </p:style>
+        <p:txBody>
+          <a:bodyPr rtlCol="0" anchor="ctr"/>
+          <a:lstStyle/>
+          <a:p>
+            <a:pPr algn="ctr"/>
+          </a:p>
+        </p:txBody>
+      </p:sp>
+      <p:sp>
+        <p:nvSpPr>
+          <p:cNvPr id="11" name="TextBox 10"/>
+          <p:cNvSpPr txBox="1"/>
+          <p:nvPr/>
+        </p:nvSpPr>
+        <p:spPr>
+          <a:xfrm>
+            <a:off x="8613648" y="1380744"/>
+            <a:ext cx="2660904" cy="4645152"/>
+          </a:xfrm>
+          <a:prstGeom prst="rect">
+            <a:avLst/>
+          </a:prstGeom>
+          <a:noFill/>
+        </p:spPr>
+        <p:txBody>
+          <a:bodyPr wrap="square" lIns="0" tIns="0" rIns="0" bIns="0">
+            <a:spAutoFit/>
+          </a:bodyPr>
+          <a:lstStyle/>
+          <a:p>
+            <a:pPr>
+              <a:spcAft>
+                <a:spcPts val="800"/>
+              </a:spcAft>
+            </a:pPr>
+            <a:r>
+              <a:rPr sz="1550" b="1">
+                <a:solidFill>
+                  <a:srgbClr val="059669"/>
+                </a:solidFill>
+              </a:rPr>
+              <a:t>4-Stage Build &amp; Setup Sequence</a:t>
+            </a:r>
+          </a:p>
+          <a:p>
+            <a:pPr>
+              <a:spcAft>
+                <a:spcPts val="600"/>
+              </a:spcAft>
+            </a:pPr>
+            <a:r>
+              <a:rPr sz="1250" b="1">
+                <a:solidFill>
+                  <a:srgbClr val="0F172A"/>
+                </a:solidFill>
+              </a:rPr>
+              <a:t>Step 1: Environment Setup </a:t>
+            </a:r>
+            <a:r>
+              <a:rPr sz="1200">
+                <a:solidFill>
+                  <a:srgbClr val="1F2937"/>
+                </a:solidFill>
+              </a:rPr>
+              <a:t>Ubuntu 24.04 LTS, Nginx 1.28, PHP 8.5-FPM &amp; MySQL 8.0 cloud instance.</a:t>
+            </a:r>
+          </a:p>
+          <a:p>
+            <a:pPr>
+              <a:spcAft>
+                <a:spcPts val="600"/>
+              </a:spcAft>
+            </a:pPr>
+            <a:r>
+              <a:rPr sz="1250" b="1">
+                <a:solidFill>
+                  <a:srgbClr val="0F172A"/>
+                </a:solidFill>
+              </a:rPr>
+              <a:t>Step 2: Hardware Interfacing </a:t>
+            </a:r>
+            <a:r>
+              <a:rPr sz="1200">
+                <a:solidFill>
+                  <a:srgbClr val="1F2937"/>
+                </a:solidFill>
+              </a:rPr>
+              <a:t>80mm ESC/POS thermal printer USB/LAN TCP binary stream &amp; 24V RJ11 solenoid circuit.</a:t>
+            </a:r>
+          </a:p>
+          <a:p>
+            <a:pPr>
+              <a:spcAft>
+                <a:spcPts val="600"/>
+              </a:spcAft>
+            </a:pPr>
+            <a:r>
+              <a:rPr sz="1250" b="1">
+                <a:solidFill>
+                  <a:srgbClr val="0F172A"/>
+                </a:solidFill>
+              </a:rPr>
+              <a:t>Step 3: Software Loading </a:t>
+            </a:r>
+            <a:r>
+              <a:rPr sz="1200">
+                <a:solidFill>
+                  <a:srgbClr val="1F2937"/>
+                </a:solidFill>
+              </a:rPr>
+              <a:t>Laravel 11 REST API, cashier Web POS SPA, and customer QR PWA.</a:t>
+            </a:r>
+          </a:p>
+          <a:p>
+            <a:pPr>
+              <a:spcAft>
+                <a:spcPts val="600"/>
+              </a:spcAft>
+            </a:pPr>
+            <a:r>
+              <a:rPr sz="1250" b="1">
+                <a:solidFill>
+                  <a:srgbClr val="0F172A"/>
+                </a:solidFill>
+              </a:rPr>
+              <a:t>Step 4: Power-on &amp; Check </a:t>
+            </a:r>
+            <a:r>
+              <a:rPr sz="1200">
+                <a:solidFill>
+                  <a:srgbClr val="1F2937"/>
+                </a:solidFill>
+              </a:rPr>
+              <a:t>Live table QR order placement, sub-145ms KDS alert, and 1.2s receipt printing.</a:t>
+            </a:r>
+          </a:p>
+        </p:txBody>
+      </p:sp>
+      <p:sp>
+        <p:nvSpPr>
+          <p:cNvPr id="12" name="Rounded Rectangle 11"/>
+          <p:cNvSpPr/>
+          <p:nvPr/>
+        </p:nvSpPr>
+        <p:spPr>
+          <a:xfrm>
+            <a:off x="731520" y="4251960"/>
+            <a:ext cx="3840480" cy="1920240"/>
           </a:xfrm>
           <a:prstGeom prst="roundRect">
             <a:avLst/>
@@ -5065,14 +5240,14 @@
       </p:sp>
       <p:sp>
         <p:nvSpPr>
-          <p:cNvPr id="11" name="TextBox 10"/>
+          <p:cNvPr id="13" name="TextBox 12"/>
           <p:cNvSpPr txBox="1"/>
           <p:nvPr/>
         </p:nvSpPr>
         <p:spPr>
           <a:xfrm>
-            <a:off x="932688" y="4718304"/>
-            <a:ext cx="4718303" cy="1399032"/>
+            <a:off x="932688" y="4398264"/>
+            <a:ext cx="3438144" cy="1627632"/>
           </a:xfrm>
           <a:prstGeom prst="rect">
             <a:avLst/>
@@ -5096,7 +5271,7 @@
                   <a:srgbClr val="1E3A8A"/>
                 </a:solidFill>
               </a:rPr>
-              <a:t>Fig 4(a): Live Web POS Terminal Interface</a:t>
+              <a:t>Fig 4(a): Live Web POS Terminal</a:t>
             </a:r>
           </a:p>
           <a:p>
@@ -5119,21 +5294,21 @@
                   <a:srgbClr val="1F2937"/>
                 </a:solidFill>
               </a:rPr>
-              <a:t>Touch-friendly table grid, live search filter, order state tracking, and express keyboard shortcuts (F1=Pay, F4=Hold, F9=KOT).</a:t>
-            </a:r>
-          </a:p>
-        </p:txBody>
-      </p:sp>
-      <p:sp>
-        <p:nvSpPr>
-          <p:cNvPr id="12" name="Rounded Rectangle 11"/>
+              <a:t>Touch table grid, live search, and F1-F9 express cashier shortcuts.</a:t>
+            </a:r>
+          </a:p>
+        </p:txBody>
+      </p:sp>
+      <p:sp>
+        <p:nvSpPr>
+          <p:cNvPr id="14" name="Rounded Rectangle 13"/>
           <p:cNvSpPr/>
           <p:nvPr/>
         </p:nvSpPr>
         <p:spPr>
           <a:xfrm>
-            <a:off x="6217920" y="4572000"/>
-            <a:ext cx="5257800" cy="1691640"/>
+            <a:off x="4754880" y="4251960"/>
+            <a:ext cx="3474720" cy="1920240"/>
           </a:xfrm>
           <a:prstGeom prst="roundRect">
             <a:avLst/>
@@ -5171,14 +5346,14 @@
       </p:sp>
       <p:sp>
         <p:nvSpPr>
-          <p:cNvPr id="13" name="TextBox 12"/>
+          <p:cNvPr id="15" name="TextBox 14"/>
           <p:cNvSpPr txBox="1"/>
           <p:nvPr/>
         </p:nvSpPr>
         <p:spPr>
           <a:xfrm>
-            <a:off x="6419088" y="4718304"/>
-            <a:ext cx="4855464" cy="1399032"/>
+            <a:off x="4956048" y="4398264"/>
+            <a:ext cx="3072384" cy="1627632"/>
           </a:xfrm>
           <a:prstGeom prst="rect">
             <a:avLst/>
@@ -5202,7 +5377,7 @@
                   <a:srgbClr val="1E3A8A"/>
                 </a:solidFill>
               </a:rPr>
-              <a:t>Fig 4(b): 80mm ESC/POS Thermal Printer Setup</a:t>
+              <a:t>Fig 4(b): ESC/POS Thermal Printer</a:t>
             </a:r>
           </a:p>
           <a:p>
@@ -5225,7 +5400,7 @@
                   <a:srgbClr val="1F2937"/>
                 </a:solidFill>
               </a:rPr>
-              <a:t>High-speed thermal printing over raw TCP socket (1.2s), automatic guillotine paper cutting, and 24V RJ11 cash drawer trigger.</a:t>
+              <a:t>80mm thermal receipt cut in 1.2s &amp; automated 24V cash drawer pop.</a:t>
             </a:r>
           </a:p>
         </p:txBody>
@@ -10070,7 +10245,7 @@
                   <a:srgbClr val="1F2937"/>
                 </a:solidFill>
               </a:rPr>
-              <a:t>Commercial POS vendors demand ₹25,000 - ₹50,000 per cash counter for proprietary terminals.</a:t>
+              <a:t>Commercial POS vendors demand ₹25,000 - ₹50,000 per counter for proprietary terminals.</a:t>
             </a:r>
           </a:p>
           <a:p>
@@ -10085,7 +10260,7 @@
                   <a:srgbClr val="0F172A"/>
                 </a:solidFill>
               </a:rPr>
-              <a:t>Recurring Squeeze: </a:t>
+              <a:t>Industry Stat: </a:t>
             </a:r>
             <a:r>
               <a:rPr sz="1200">
@@ -10093,7 +10268,7 @@
                   <a:srgbClr val="1F2937"/>
                 </a:solidFill>
               </a:rPr>
-              <a:t>Annual maintenance contracts (AMC) and forced payment gateway fees strain independent restaurant margins.</a:t>
+              <a:t>Over 68% of food SMEs in India cannot afford dedicated POS hardware terminals (NRAI 2025 Report).</a:t>
             </a:r>
           </a:p>
         </p:txBody>
@@ -10199,7 +10374,7 @@
                   <a:srgbClr val="1F2937"/>
                 </a:solidFill>
               </a:rPr>
-              <a:t>Manual handwritten KOTs walk to kitchen, causing 8-14 minutes communication lag during peak dining rushes.</a:t>
+              <a:t>Manual handwritten KOTs cause 8-14 minutes communication lag during peak dining rushes.</a:t>
             </a:r>
           </a:p>
           <a:p>
@@ -10472,7 +10647,7 @@
                   <a:srgbClr val="0F172A"/>
                 </a:solidFill>
               </a:rPr>
-              <a:t>Shrinkage: </a:t>
+              <a:t>Who Benefits: </a:t>
             </a:r>
             <a:r>
               <a:rPr sz="1200">
@@ -10480,7 +10655,7 @@
                   <a:srgbClr val="1F2937"/>
                 </a:solidFill>
               </a:rPr>
-              <a:t>Untracked raw ingredients allow 12-18% unaccounted kitchen shrinkage and pilferage.</a:t>
+              <a:t>25,000+ independent eateries, cafe operators, kitchen cooks, and dining guests benefit from an automated fix.</a:t>
             </a:r>
           </a:p>
         </p:txBody>

</xml_diff>

<commit_message>
docs(gtu): synchronize all 4 team members across Report, Presentation, Logbook, and standalone GitHub Summary
</commit_message>
<xml_diff>
--- a/docs/DineFlow_AI_GTU_Minor_Project_Presentation.pptx
+++ b/docs/DineFlow_AI_GTU_Minor_Project_Presentation.pptx
@@ -3406,8 +3406,8 @@
         </p:nvSpPr>
         <p:spPr>
           <a:xfrm>
-            <a:off x="914400" y="4343400"/>
-            <a:ext cx="5029200" cy="2011680"/>
+            <a:off x="731520" y="4251960"/>
+            <a:ext cx="5303520" cy="2240280"/>
           </a:xfrm>
           <a:prstGeom prst="roundRect">
             <a:avLst/>
@@ -3451,8 +3451,8 @@
         </p:nvSpPr>
         <p:spPr>
           <a:xfrm>
-            <a:off x="1115568" y="4489704"/>
-            <a:ext cx="4626864" cy="1719072"/>
+            <a:off x="932688" y="4398264"/>
+            <a:ext cx="4901183" cy="1947672"/>
           </a:xfrm>
           <a:prstGeom prst="rect">
             <a:avLst/>
@@ -3476,7 +3476,7 @@
                   <a:srgbClr val="1E3A8A"/>
                 </a:solidFill>
               </a:rPr>
-              <a:t>Candidate &amp; Project Lead</a:t>
+              <a:t>Project Team Members (5th Sem CE)</a:t>
             </a:r>
           </a:p>
           <a:p>
@@ -3491,7 +3491,7 @@
                   <a:srgbClr val="0F172A"/>
                 </a:solidFill>
               </a:rPr>
-              <a:t>Student Name: </a:t>
+              <a:t>1. Shubh Patel (TL): </a:t>
             </a:r>
             <a:r>
               <a:rPr sz="1200">
@@ -3499,7 +3499,7 @@
                   <a:srgbClr val="1F2937"/>
                 </a:solidFill>
               </a:rPr>
-              <a:t>PATEL SHUBH MAHESHKUMAR</a:t>
+              <a:t>246310307123  |  Architecture &amp; Cloud</a:t>
             </a:r>
           </a:p>
           <a:p>
@@ -3514,7 +3514,7 @@
                   <a:srgbClr val="0F172A"/>
                 </a:solidFill>
               </a:rPr>
-              <a:t>Enrolment No: </a:t>
+              <a:t>2. Krushank Dave: </a:t>
             </a:r>
             <a:r>
               <a:rPr sz="1200">
@@ -3522,7 +3522,7 @@
                   <a:srgbClr val="1F2937"/>
                 </a:solidFill>
               </a:rPr>
-              <a:t>246310307123</a:t>
+              <a:t>246310307028  |  Web POS &amp; Shortcuts</a:t>
             </a:r>
           </a:p>
           <a:p>
@@ -3537,7 +3537,7 @@
                   <a:srgbClr val="0F172A"/>
                 </a:solidFill>
               </a:rPr>
-              <a:t>Program &amp; Sem: </a:t>
+              <a:t>3. Fiyans Patel: </a:t>
             </a:r>
             <a:r>
               <a:rPr sz="1200">
@@ -3545,7 +3545,7 @@
                   <a:srgbClr val="1F2937"/>
                 </a:solidFill>
               </a:rPr>
-              <a:t>Diploma Computer Engineering (Sem 5)</a:t>
+              <a:t>246310307090  |  ERP, Recipe BOM &amp; QR</a:t>
             </a:r>
           </a:p>
           <a:p>
@@ -3560,7 +3560,7 @@
                   <a:srgbClr val="0F172A"/>
                 </a:solidFill>
               </a:rPr>
-              <a:t>Institutional Role: </a:t>
+              <a:t>4. Veer Prajapati: </a:t>
             </a:r>
             <a:r>
               <a:rPr sz="1200">
@@ -3568,7 +3568,7 @@
                   <a:srgbClr val="1F2937"/>
                 </a:solidFill>
               </a:rPr>
-              <a:t>Team Lead / Full-Stack &amp; Cloud Engineer</a:t>
+              <a:t>246310307147  |  Cart UI &amp; KDS Stepper</a:t>
             </a:r>
           </a:p>
         </p:txBody>
@@ -3581,8 +3581,8 @@
         </p:nvSpPr>
         <p:spPr>
           <a:xfrm>
-            <a:off x="6248095" y="4343400"/>
-            <a:ext cx="5029200" cy="2011680"/>
+            <a:off x="6172200" y="4251960"/>
+            <a:ext cx="5303520" cy="2240280"/>
           </a:xfrm>
           <a:prstGeom prst="roundRect">
             <a:avLst/>
@@ -3626,8 +3626,8 @@
         </p:nvSpPr>
         <p:spPr>
           <a:xfrm>
-            <a:off x="6449263" y="4489704"/>
-            <a:ext cx="4626864" cy="1719072"/>
+            <a:off x="6373368" y="4398264"/>
+            <a:ext cx="4901183" cy="1947672"/>
           </a:xfrm>
           <a:prstGeom prst="rect">
             <a:avLst/>
@@ -3674,7 +3674,7 @@
                   <a:srgbClr val="1F2937"/>
                 </a:solidFill>
               </a:rPr>
-              <a:t>Prof. Yagnesh Patel</a:t>
+              <a:t>Prof. Yagnesh Patel (Lecturer, Comp. Engg.)</a:t>
             </a:r>
           </a:p>
           <a:p>
@@ -3689,7 +3689,7 @@
                   <a:srgbClr val="0F172A"/>
                 </a:solidFill>
               </a:rPr>
-              <a:t>Designation: </a:t>
+              <a:t>Head of Dept: </a:t>
             </a:r>
             <a:r>
               <a:rPr sz="1200">
@@ -3697,7 +3697,7 @@
                   <a:srgbClr val="1F2937"/>
                 </a:solidFill>
               </a:rPr>
-              <a:t>Lecturer, Computer Engineering Dept.</a:t>
+              <a:t>Dr. Chirag D. Patel (HOD, Comp. Engg.)</a:t>
             </a:r>
           </a:p>
           <a:p>
@@ -3712,7 +3712,7 @@
                   <a:srgbClr val="0F172A"/>
                 </a:solidFill>
               </a:rPr>
-              <a:t>Head of Dept: </a:t>
+              <a:t>Principal: </a:t>
             </a:r>
             <a:r>
               <a:rPr sz="1200">
@@ -3720,7 +3720,7 @@
                   <a:srgbClr val="1F2937"/>
                 </a:solidFill>
               </a:rPr>
-              <a:t>Dr. Chirag D. Patel (HOD, Computer Engg.)</a:t>
+              <a:t>Shri H. C. Parmar (K. D. Polytechnic, Patan)</a:t>
             </a:r>
           </a:p>
           <a:p>
@@ -3735,7 +3735,7 @@
                   <a:srgbClr val="0F172A"/>
                 </a:solidFill>
               </a:rPr>
-              <a:t>Principal: </a:t>
+              <a:t>Institution: </a:t>
             </a:r>
             <a:r>
               <a:rPr sz="1200">
@@ -3743,7 +3743,7 @@
                   <a:srgbClr val="1F2937"/>
                 </a:solidFill>
               </a:rPr>
-              <a:t>Shri H. C. Parmar, K. D. Polytechnic, Patan</a:t>
+              <a:t>K. D. Polytechnic, Patan (GTU Code: 631)</a:t>
             </a:r>
           </a:p>
         </p:txBody>
@@ -9034,7 +9034,7 @@
                   <a:srgbClr val="059669"/>
                 </a:solidFill>
               </a:rPr>
-              <a:t>Project Author &amp; Department Details</a:t>
+              <a:t>Project Team &amp; Department Details</a:t>
             </a:r>
           </a:p>
           <a:p>
@@ -9049,7 +9049,7 @@
                   <a:srgbClr val="0F172A"/>
                 </a:solidFill>
               </a:rPr>
-              <a:t>Candidate Name: </a:t>
+              <a:t>Project Team: </a:t>
             </a:r>
             <a:r>
               <a:rPr sz="1200">
@@ -9057,7 +9057,8 @@
                   <a:srgbClr val="1F2937"/>
                 </a:solidFill>
               </a:rPr>
-              <a:t>PATEL SHUBH MAHESHKUMAR</a:t>
+              <a:t>Shubh Patel (TL), Krushank Dave,
+Fiyans Patel, Veer Prajapati</a:t>
             </a:r>
           </a:p>
           <a:p>
@@ -9072,7 +9073,7 @@
                   <a:srgbClr val="0F172A"/>
                 </a:solidFill>
               </a:rPr>
-              <a:t>Enrolment Number: </a:t>
+              <a:t>GTU Enrolments: </a:t>
             </a:r>
             <a:r>
               <a:rPr sz="1200">
@@ -9080,7 +9081,8 @@
                   <a:srgbClr val="1F2937"/>
                 </a:solidFill>
               </a:rPr>
-              <a:t>246310307123 (Semester 5th)</a:t>
+              <a:t>246310307123, 246310307028,
+246310307090, 246310307147</a:t>
             </a:r>
           </a:p>
           <a:p>
@@ -9118,7 +9120,7 @@
                   <a:srgbClr val="0F172A"/>
                 </a:solidFill>
               </a:rPr>
-              <a:t>Head of Department: </a:t>
+              <a:t>Head of Dept: </a:t>
             </a:r>
             <a:r>
               <a:rPr sz="1200">
@@ -9126,7 +9128,7 @@
                   <a:srgbClr val="1F2937"/>
                 </a:solidFill>
               </a:rPr>
-              <a:t>Dr. Chirag D. Patel</a:t>
+              <a:t>Dr. Chirag D. Patel (HOD, Comp. Engg.)</a:t>
             </a:r>
           </a:p>
           <a:p>

</xml_diff>